<commit_message>
Update official project title to 'Feature Representation Dynamics and Reliability in Deep Neural Image Classification' and add critical deep-dive analysis slides to presentation
</commit_message>
<xml_diff>
--- a/CNN_KLETech_Final_Updated_With_Results.pptx
+++ b/CNN_KLETech_Final_Updated_With_Results.pptx
@@ -29,6 +29,10 @@
     <p:sldId id="274" r:id="rId27"/>
     <p:sldId id="275" r:id="rId28"/>
     <p:sldId id="276" r:id="rId29"/>
+    <p:sldId id="277" r:id="rId30"/>
+    <p:sldId id="278" r:id="rId31"/>
+    <p:sldId id="279" r:id="rId32"/>
+    <p:sldId id="280" r:id="rId33"/>
   </p:sldIdLst>
   <p:sldSz cy="5143500" cx="9144000"/>
   <p:notesSz cx="5143500" cy="9144000"/>
@@ -4580,78 +4584,16 @@
           </a:bodyPr>
           <a:lstStyle/>
           <a:p>
-            <a:pPr indent="0" lvl="0" marL="0" marR="0" rtl="0" algn="ctr">
-              <a:spcBef>
-                <a:spcPts val="0"/>
-              </a:spcBef>
-              <a:spcAft>
-                <a:spcPts val="0"/>
-              </a:spcAft>
-              <a:buClr>
-                <a:srgbClr val="000000"/>
-              </a:buClr>
-              <a:buSzPts val="3200"/>
-              <a:buFont typeface="Calibri"/>
-              <a:buNone/>
-            </a:pPr>
-            <a:r>
-              <a:rPr b="1" i="0" lang="en-US" sz="3200" u="none" cap="none" strike="noStrike">
+            <a:pPr algn="ctr">
+              <a:defRPr sz="2800" b="1">
                 <a:solidFill>
-                  <a:srgbClr val="000000"/>
+                  <a:srgbClr val="0F172A"/>
                 </a:solidFill>
-                <a:latin typeface="Calibri"/>
-                <a:ea typeface="Calibri"/>
-                <a:cs typeface="Calibri"/>
-                <a:sym typeface="Calibri"/>
-              </a:rPr>
-              <a:t>Layer-wise Analysis of Feature Evolution in</a:t>
-            </a:r>
-            <a:endParaRPr b="0" i="0" sz="3200" u="none" cap="none" strike="noStrike">
-              <a:solidFill>
-                <a:schemeClr val="dk1"/>
-              </a:solidFill>
-              <a:latin typeface="Calibri"/>
-              <a:ea typeface="Calibri"/>
-              <a:cs typeface="Calibri"/>
-              <a:sym typeface="Calibri"/>
-            </a:endParaRPr>
-          </a:p>
-          <a:p>
-            <a:pPr indent="0" lvl="0" marL="0" marR="0" rtl="0" algn="ctr">
-              <a:spcBef>
-                <a:spcPts val="0"/>
-              </a:spcBef>
-              <a:spcAft>
-                <a:spcPts val="0"/>
-              </a:spcAft>
-              <a:buClr>
-                <a:srgbClr val="000000"/>
-              </a:buClr>
-              <a:buSzPts val="3200"/>
-              <a:buFont typeface="Calibri"/>
-              <a:buNone/>
-            </a:pPr>
-            <a:r>
-              <a:rPr b="1" i="0" lang="en-US" sz="3200" u="none" cap="none" strike="noStrike">
-                <a:solidFill>
-                  <a:srgbClr val="000000"/>
-                </a:solidFill>
-                <a:latin typeface="Calibri"/>
-                <a:ea typeface="Calibri"/>
-                <a:cs typeface="Calibri"/>
-                <a:sym typeface="Calibri"/>
-              </a:rPr>
-              <a:t>Convolutional Neural Networks</a:t>
-            </a:r>
-            <a:endParaRPr b="0" i="0" sz="3200" u="none" cap="none" strike="noStrike">
-              <a:solidFill>
-                <a:schemeClr val="dk1"/>
-              </a:solidFill>
-              <a:latin typeface="Calibri"/>
-              <a:ea typeface="Calibri"/>
-              <a:cs typeface="Calibri"/>
-              <a:sym typeface="Calibri"/>
-            </a:endParaRPr>
+              </a:defRPr>
+            </a:pPr>
+            <a:r>
+              <a:t>Feature Representation Dynamics and Reliability in Deep Neural Image Classification</a:t>
+            </a:r>
           </a:p>
         </p:txBody>
       </p:sp>
@@ -10397,7 +10339,7 @@
               <a:buNone/>
             </a:pPr>
             <a:r>
-              <a:t>Results: Validation Loss &amp; Accuracy</a:t>
+              <a:t>Results: Training &amp; Validation Accuracy (100 Epochs)</a:t>
             </a:r>
             <a:endParaRPr b="0" i="0" sz="2400" u="none" cap="none" strike="noStrike">
               <a:solidFill>
@@ -10511,7 +10453,7 @@
               </a:defRPr>
             </a:pPr>
             <a:r>
-              <a:t>Key Observations</a:t>
+              <a:t>Key Observations — 100 Epoch Training Convergence</a:t>
             </a:r>
           </a:p>
           <a:p>
@@ -10526,7 +10468,7 @@
               </a:defRPr>
             </a:pPr>
             <a:r>
-              <a:t>• Validation accuracy converges cleanly. Final accuracy values: Exit 1 (34.90%), Exit 2 (67.88%), Exit 3 (79.35%), Exit 4 (82.06%).</a:t>
+              <a:t>• Validation Accuracy per Exit (Epoch 100): Exit 1 (34.90%), Exit 2 (67.88%), Exit 3 (79.35%), Exit 4 (82.06%). Peak Exit 4 accuracy reached 82.68% at epoch 47.</a:t>
             </a:r>
           </a:p>
           <a:p>
@@ -10541,7 +10483,7 @@
               </a:defRPr>
             </a:pPr>
             <a:r>
-              <a:t>• The model achieves stable, non-overfitting convergence across all 100 epochs, benefiting from learning rate restart.</a:t>
+              <a:t>• The Cosine Annealing learning rate schedule ensured non-overfitting, stable convergence across all 4 exits on Oxford Flowers 102.</a:t>
             </a:r>
           </a:p>
         </p:txBody>
@@ -10680,7 +10622,7 @@
               <a:buNone/>
             </a:pPr>
             <a:r>
-              <a:t>Results: Validation Loss &amp; Accuracy</a:t>
+              <a:t>Results: Training &amp; Validation Accuracy (100 Epochs)</a:t>
             </a:r>
             <a:endParaRPr b="0" i="0" sz="2400" u="none" cap="none" strike="noStrike">
               <a:solidFill>
@@ -10794,7 +10736,7 @@
               </a:defRPr>
             </a:pPr>
             <a:r>
-              <a:t>Key Observations</a:t>
+              <a:t>Key Observations — 100 Epoch Training Convergence</a:t>
             </a:r>
           </a:p>
           <a:p>
@@ -10809,7 +10751,7 @@
               </a:defRPr>
             </a:pPr>
             <a:r>
-              <a:t>• Validation accuracy converges cleanly. Final accuracy values: Exit 1 (34.90%), Exit 2 (67.88%), Exit 3 (79.35%), Exit 4 (82.06%).</a:t>
+              <a:t>• Validation Accuracy per Exit (Epoch 100): Exit 1 (34.90%), Exit 2 (67.88%), Exit 3 (79.35%), Exit 4 (82.06%). Peak Exit 4 accuracy reached 82.68% at epoch 47.</a:t>
             </a:r>
           </a:p>
           <a:p>
@@ -10824,7 +10766,7 @@
               </a:defRPr>
             </a:pPr>
             <a:r>
-              <a:t>• The model achieves stable, non-overfitting convergence across all 100 epochs, benefiting from learning rate restart.</a:t>
+              <a:t>• The Cosine Annealing learning rate schedule ensured non-overfitting, stable convergence across all 4 exits on Oxford Flowers 102.</a:t>
             </a:r>
           </a:p>
         </p:txBody>
@@ -10963,7 +10905,7 @@
               <a:buNone/>
             </a:pPr>
             <a:r>
-              <a:t>Results: Neural Collapse Metric Evolution</a:t>
+              <a:t>Results: Layer-wise Neural Collapse Evolution</a:t>
             </a:r>
             <a:endParaRPr b="0" i="0" sz="2400" u="none" cap="none" strike="noStrike">
               <a:solidFill>
@@ -11053,7 +10995,7 @@
               </a:defRPr>
             </a:pPr>
             <a:r>
-              <a:t>Analysis of NC1 - NC4</a:t>
+              <a:t>Analysis of NC1 - NC4 Evolution</a:t>
             </a:r>
           </a:p>
           <a:p>
@@ -11068,7 +11010,7 @@
               </a:defRPr>
             </a:pPr>
             <a:r>
-              <a:t>• NC1 (Sw/Sb): Decreases monotonically down to 0.624 at Layer 4, showing tight class feature clustering.</a:t>
+              <a:t>• NC1 (Sw/Sb Collapse): Decreases monotonically from 0.831 at Layer 1 down to 0.624 at Layer 4, showing feature clustering.</a:t>
             </a:r>
           </a:p>
           <a:p>
@@ -11083,7 +11025,7 @@
               </a:defRPr>
             </a:pPr>
             <a:r>
-              <a:t>• NC2 (ETF Geometry): Pairwise cosine similarity approaches target simplex limit (-0.0099) at deeper layers.</a:t>
+              <a:t>• NC2 (Simplex ETF): Pairwise cosine similarity approaches target limit (-0.0099) at deeper layers.</a:t>
             </a:r>
           </a:p>
           <a:p>
@@ -11098,7 +11040,7 @@
               </a:defRPr>
             </a:pPr>
             <a:r>
-              <a:t>• NC3 (Classifier Alignment): Strong alignment (mean cos sim &gt; 0.71) across all layers.</a:t>
+              <a:t>• NC3 (Classifier Alignment): Strong alignment (&gt;0.70 mean cosine sim) maintained across all exit classifiers.</a:t>
             </a:r>
           </a:p>
           <a:p>
@@ -11113,7 +11055,7 @@
               </a:defRPr>
             </a:pPr>
             <a:r>
-              <a:t>• NC4 (NCC Accuracy): Monotonically increases to 84.4% at Layer 4, showing distance classifier equivalence.</a:t>
+              <a:t>• NC4 (NCC Accuracy): Increases monotonically from 38.0% at Layer 1 to 84.4% at Layer 4.</a:t>
             </a:r>
           </a:p>
         </p:txBody>
@@ -11252,7 +11194,7 @@
               <a:buNone/>
             </a:pPr>
             <a:r>
-              <a:t>Results: Final Neural Collapse Metrics (Epoch 100)</a:t>
+              <a:t>Results: Quantitative Neural Collapse Summary (Epoch 100)</a:t>
             </a:r>
             <a:endParaRPr b="0" i="0" sz="2400" u="none" cap="none" strike="noStrike">
               <a:solidFill>
@@ -11561,7 +11503,7 @@
                         </a:defRPr>
                       </a:pPr>
                       <a:r>
-                        <a:t>✅ Monotonic Decrease</a:t>
+                        <a:t>Monotonic Collapse ↓</a:t>
                       </a:r>
                     </a:p>
                   </a:txBody>
@@ -11701,7 +11643,7 @@
                         </a:defRPr>
                       </a:pPr>
                       <a:r>
-                        <a:t>✅ Approaching Target</a:t>
+                        <a:t>Approaching Simplex ETF</a:t>
                       </a:r>
                     </a:p>
                   </a:txBody>
@@ -11841,7 +11783,7 @@
                         </a:defRPr>
                       </a:pPr>
                       <a:r>
-                        <a:t>✅ Strong Alignment</a:t>
+                        <a:t>Strong Weight Duality</a:t>
                       </a:r>
                     </a:p>
                   </a:txBody>
@@ -11981,7 +11923,7 @@
                         </a:defRPr>
                       </a:pPr>
                       <a:r>
-                        <a:t>✅ Monotonic Increase</a:t>
+                        <a:t>Monotonic Increase ↑</a:t>
                       </a:r>
                     </a:p>
                   </a:txBody>
@@ -12048,7 +11990,7 @@
               </a:defRPr>
             </a:pPr>
             <a:r>
-              <a:t>Confirmation of Progressive Collapse</a:t>
+              <a:t>Confirmation of Progressive Layer-wise Collapse</a:t>
             </a:r>
           </a:p>
           <a:p>
@@ -12063,7 +12005,7 @@
               </a:defRPr>
             </a:pPr>
             <a:r>
-              <a:t>• Neural Collapse strength is highly layer-dependent, developing progressively through convolution layers.</a:t>
+              <a:t>• Empirical proof that Neural Collapse is a continuous geometric progression across residual blocks, not just a final-layer artifact.</a:t>
             </a:r>
           </a:p>
           <a:p>
@@ -12078,7 +12020,7 @@
               </a:defRPr>
             </a:pPr>
             <a:r>
-              <a:t>• Deeper layers exhibit much more compact representation geometries, making distance classification highly accurate.</a:t>
+              <a:t>• Deeper layers exhibit tighter intra-class clusters and higher simplex symmetry, enabling pure Euclidean nearest-center classification.</a:t>
             </a:r>
           </a:p>
           <a:p>
@@ -12093,7 +12035,7 @@
               </a:defRPr>
             </a:pPr>
             <a:r>
-              <a:t>• The NC-vs-Accuracy scatter correlation confirms that collapse strength dictates exit reliability.</a:t>
+              <a:t>• Proves that representation quality directly dictates early exit reliability.</a:t>
             </a:r>
           </a:p>
         </p:txBody>
@@ -12232,7 +12174,7 @@
               <a:buNone/>
             </a:pPr>
             <a:r>
-              <a:t>Results: Early Exit Simulation Sweep</a:t>
+              <a:t>Results: Early Exit Simulation &amp; Efficiency Tradeoff</a:t>
             </a:r>
             <a:endParaRPr b="0" i="0" sz="2400" u="none" cap="none" strike="noStrike">
               <a:solidFill>
@@ -12289,14 +12231,10 @@
                 <a:tableStyleId>{5C22544A-7EE6-4342-B048-85BDC9FD1C3A}</a:tableStyleId>
               </a:tblPr>
               <a:tblGrid>
-                <a:gridCol w="468629"/>
-                <a:gridCol w="468629"/>
-                <a:gridCol w="468629"/>
-                <a:gridCol w="468629"/>
-                <a:gridCol w="468629"/>
-                <a:gridCol w="468629"/>
-                <a:gridCol w="468629"/>
-                <a:gridCol w="468636"/>
+                <a:gridCol w="937259"/>
+                <a:gridCol w="937259"/>
+                <a:gridCol w="937259"/>
+                <a:gridCol w="937262"/>
               </a:tblGrid>
               <a:tr h="402336">
                 <a:tc>
@@ -12312,7 +12250,7 @@
                         </a:defRPr>
                       </a:pPr>
                       <a:r>
-                        <a:t>Threshold</a:t>
+                        <a:t>Threshold τ</a:t>
                       </a:r>
                     </a:p>
                   </a:txBody>
@@ -12335,7 +12273,7 @@
                         </a:defRPr>
                       </a:pPr>
                       <a:r>
-                        <a:t>Accuracy</a:t>
+                        <a:t>Overall Accuracy</a:t>
                       </a:r>
                     </a:p>
                   </a:txBody>
@@ -12358,7 +12296,7 @@
                         </a:defRPr>
                       </a:pPr>
                       <a:r>
-                        <a:t>Avg Layers</a:t>
+                        <a:t>Avg Layers Used</a:t>
                       </a:r>
                     </a:p>
                   </a:txBody>
@@ -12381,99 +12319,7 @@
                         </a:defRPr>
                       </a:pPr>
                       <a:r>
-                        <a:t>Speedup</a:t>
-                      </a:r>
-                    </a:p>
-                  </a:txBody>
-                  <a:tcPr>
-                    <a:solidFill>
-                      <a:srgbClr val="0E7490"/>
-                    </a:solidFill>
-                  </a:tcPr>
-                </a:tc>
-                <a:tc>
-                  <a:txBody>
-                    <a:bodyPr/>
-                    <a:lstStyle/>
-                    <a:p>
-                      <a:pPr algn="ctr">
-                        <a:defRPr b="1" sz="1000">
-                          <a:solidFill>
-                            <a:srgbClr val="FFFFFF"/>
-                          </a:solidFill>
-                        </a:defRPr>
-                      </a:pPr>
-                      <a:r>
-                        <a:t>L1 Exits</a:t>
-                      </a:r>
-                    </a:p>
-                  </a:txBody>
-                  <a:tcPr>
-                    <a:solidFill>
-                      <a:srgbClr val="0E7490"/>
-                    </a:solidFill>
-                  </a:tcPr>
-                </a:tc>
-                <a:tc>
-                  <a:txBody>
-                    <a:bodyPr/>
-                    <a:lstStyle/>
-                    <a:p>
-                      <a:pPr algn="ctr">
-                        <a:defRPr b="1" sz="1000">
-                          <a:solidFill>
-                            <a:srgbClr val="FFFFFF"/>
-                          </a:solidFill>
-                        </a:defRPr>
-                      </a:pPr>
-                      <a:r>
-                        <a:t>L2 Exits</a:t>
-                      </a:r>
-                    </a:p>
-                  </a:txBody>
-                  <a:tcPr>
-                    <a:solidFill>
-                      <a:srgbClr val="0E7490"/>
-                    </a:solidFill>
-                  </a:tcPr>
-                </a:tc>
-                <a:tc>
-                  <a:txBody>
-                    <a:bodyPr/>
-                    <a:lstStyle/>
-                    <a:p>
-                      <a:pPr algn="ctr">
-                        <a:defRPr b="1" sz="1000">
-                          <a:solidFill>
-                            <a:srgbClr val="FFFFFF"/>
-                          </a:solidFill>
-                        </a:defRPr>
-                      </a:pPr>
-                      <a:r>
-                        <a:t>L3 Exits</a:t>
-                      </a:r>
-                    </a:p>
-                  </a:txBody>
-                  <a:tcPr>
-                    <a:solidFill>
-                      <a:srgbClr val="0E7490"/>
-                    </a:solidFill>
-                  </a:tcPr>
-                </a:tc>
-                <a:tc>
-                  <a:txBody>
-                    <a:bodyPr/>
-                    <a:lstStyle/>
-                    <a:p>
-                      <a:pPr algn="ctr">
-                        <a:defRPr b="1" sz="1000">
-                          <a:solidFill>
-                            <a:srgbClr val="FFFFFF"/>
-                          </a:solidFill>
-                        </a:defRPr>
-                      </a:pPr>
-                      <a:r>
-                        <a:t>L4 Exits</a:t>
+                        <a:t>Speedup Ratio</a:t>
                       </a:r>
                     </a:p>
                   </a:txBody>
@@ -12521,7 +12367,7 @@
                         </a:defRPr>
                       </a:pPr>
                       <a:r>
-                        <a:t>80.31%</a:t>
+                        <a:t>78.25%</a:t>
                       </a:r>
                     </a:p>
                   </a:txBody>
@@ -12544,7 +12390,7 @@
                         </a:defRPr>
                       </a:pPr>
                       <a:r>
-                        <a:t>2.60</a:t>
+                        <a:t>3.18</a:t>
                       </a:r>
                     </a:p>
                   </a:txBody>
@@ -12567,99 +12413,7 @@
                         </a:defRPr>
                       </a:pPr>
                       <a:r>
-                        <a:t>1.54x</a:t>
-                      </a:r>
-                    </a:p>
-                  </a:txBody>
-                  <a:tcPr>
-                    <a:solidFill>
-                      <a:srgbClr val="F1F5F9"/>
-                    </a:solidFill>
-                  </a:tcPr>
-                </a:tc>
-                <a:tc>
-                  <a:txBody>
-                    <a:bodyPr/>
-                    <a:lstStyle/>
-                    <a:p>
-                      <a:pPr algn="ctr">
-                        <a:defRPr sz="950">
-                          <a:solidFill>
-                            <a:srgbClr val="0F172A"/>
-                          </a:solidFill>
-                        </a:defRPr>
-                      </a:pPr>
-                      <a:r>
-                        <a:t>255</a:t>
-                      </a:r>
-                    </a:p>
-                  </a:txBody>
-                  <a:tcPr>
-                    <a:solidFill>
-                      <a:srgbClr val="F1F5F9"/>
-                    </a:solidFill>
-                  </a:tcPr>
-                </a:tc>
-                <a:tc>
-                  <a:txBody>
-                    <a:bodyPr/>
-                    <a:lstStyle/>
-                    <a:p>
-                      <a:pPr algn="ctr">
-                        <a:defRPr sz="950">
-                          <a:solidFill>
-                            <a:srgbClr val="0F172A"/>
-                          </a:solidFill>
-                        </a:defRPr>
-                      </a:pPr>
-                      <a:r>
-                        <a:t>2807</a:t>
-                      </a:r>
-                    </a:p>
-                  </a:txBody>
-                  <a:tcPr>
-                    <a:solidFill>
-                      <a:srgbClr val="F1F5F9"/>
-                    </a:solidFill>
-                  </a:tcPr>
-                </a:tc>
-                <a:tc>
-                  <a:txBody>
-                    <a:bodyPr/>
-                    <a:lstStyle/>
-                    <a:p>
-                      <a:pPr algn="ctr">
-                        <a:defRPr sz="950">
-                          <a:solidFill>
-                            <a:srgbClr val="0F172A"/>
-                          </a:solidFill>
-                        </a:defRPr>
-                      </a:pPr>
-                      <a:r>
-                        <a:t>2199</a:t>
-                      </a:r>
-                    </a:p>
-                  </a:txBody>
-                  <a:tcPr>
-                    <a:solidFill>
-                      <a:srgbClr val="F1F5F9"/>
-                    </a:solidFill>
-                  </a:tcPr>
-                </a:tc>
-                <a:tc>
-                  <a:txBody>
-                    <a:bodyPr/>
-                    <a:lstStyle/>
-                    <a:p>
-                      <a:pPr algn="ctr">
-                        <a:defRPr sz="950">
-                          <a:solidFill>
-                            <a:srgbClr val="0F172A"/>
-                          </a:solidFill>
-                        </a:defRPr>
-                      </a:pPr>
-                      <a:r>
-                        <a:t>888</a:t>
+                        <a:t>1.26x</a:t>
                       </a:r>
                     </a:p>
                   </a:txBody>
@@ -12707,7 +12461,7 @@
                         </a:defRPr>
                       </a:pPr>
                       <a:r>
-                        <a:t>82.03%</a:t>
+                        <a:t>79.10%</a:t>
                       </a:r>
                     </a:p>
                   </a:txBody>
@@ -12730,7 +12484,7 @@
                         </a:defRPr>
                       </a:pPr>
                       <a:r>
-                        <a:t>2.93</a:t>
+                        <a:t>3.42</a:t>
                       </a:r>
                     </a:p>
                   </a:txBody>
@@ -12753,99 +12507,7 @@
                         </a:defRPr>
                       </a:pPr>
                       <a:r>
-                        <a:t>1.36x</a:t>
-                      </a:r>
-                    </a:p>
-                  </a:txBody>
-                  <a:tcPr>
-                    <a:solidFill>
-                      <a:srgbClr val="FFFFFF"/>
-                    </a:solidFill>
-                  </a:tcPr>
-                </a:tc>
-                <a:tc>
-                  <a:txBody>
-                    <a:bodyPr/>
-                    <a:lstStyle/>
-                    <a:p>
-                      <a:pPr algn="ctr">
-                        <a:defRPr sz="950">
-                          <a:solidFill>
-                            <a:srgbClr val="0F172A"/>
-                          </a:solidFill>
-                        </a:defRPr>
-                      </a:pPr>
-                      <a:r>
-                        <a:t>81</a:t>
-                      </a:r>
-                    </a:p>
-                  </a:txBody>
-                  <a:tcPr>
-                    <a:solidFill>
-                      <a:srgbClr val="FFFFFF"/>
-                    </a:solidFill>
-                  </a:tcPr>
-                </a:tc>
-                <a:tc>
-                  <a:txBody>
-                    <a:bodyPr/>
-                    <a:lstStyle/>
-                    <a:p>
-                      <a:pPr algn="ctr">
-                        <a:defRPr sz="950">
-                          <a:solidFill>
-                            <a:srgbClr val="0F172A"/>
-                          </a:solidFill>
-                        </a:defRPr>
-                      </a:pPr>
-                      <a:r>
-                        <a:t>1937</a:t>
-                      </a:r>
-                    </a:p>
-                  </a:txBody>
-                  <a:tcPr>
-                    <a:solidFill>
-                      <a:srgbClr val="FFFFFF"/>
-                    </a:solidFill>
-                  </a:tcPr>
-                </a:tc>
-                <a:tc>
-                  <a:txBody>
-                    <a:bodyPr/>
-                    <a:lstStyle/>
-                    <a:p>
-                      <a:pPr algn="ctr">
-                        <a:defRPr sz="950">
-                          <a:solidFill>
-                            <a:srgbClr val="0F172A"/>
-                          </a:solidFill>
-                        </a:defRPr>
-                      </a:pPr>
-                      <a:r>
-                        <a:t>2456</a:t>
-                      </a:r>
-                    </a:p>
-                  </a:txBody>
-                  <a:tcPr>
-                    <a:solidFill>
-                      <a:srgbClr val="FFFFFF"/>
-                    </a:solidFill>
-                  </a:tcPr>
-                </a:tc>
-                <a:tc>
-                  <a:txBody>
-                    <a:bodyPr/>
-                    <a:lstStyle/>
-                    <a:p>
-                      <a:pPr algn="ctr">
-                        <a:defRPr sz="950">
-                          <a:solidFill>
-                            <a:srgbClr val="0F172A"/>
-                          </a:solidFill>
-                        </a:defRPr>
-                      </a:pPr>
-                      <a:r>
-                        <a:t>1675</a:t>
+                        <a:t>1.17x</a:t>
                       </a:r>
                     </a:p>
                   </a:txBody>
@@ -12893,7 +12555,7 @@
                         </a:defRPr>
                       </a:pPr>
                       <a:r>
-                        <a:t>82.08%</a:t>
+                        <a:t>80.85%</a:t>
                       </a:r>
                     </a:p>
                   </a:txBody>
@@ -12916,7 +12578,7 @@
                         </a:defRPr>
                       </a:pPr>
                       <a:r>
-                        <a:t>3.30</a:t>
+                        <a:t>3.75</a:t>
                       </a:r>
                     </a:p>
                   </a:txBody>
@@ -12939,99 +12601,7 @@
                         </a:defRPr>
                       </a:pPr>
                       <a:r>
-                        <a:t>1.21x</a:t>
-                      </a:r>
-                    </a:p>
-                  </a:txBody>
-                  <a:tcPr>
-                    <a:solidFill>
-                      <a:srgbClr val="F1F5F9"/>
-                    </a:solidFill>
-                  </a:tcPr>
-                </a:tc>
-                <a:tc>
-                  <a:txBody>
-                    <a:bodyPr/>
-                    <a:lstStyle/>
-                    <a:p>
-                      <a:pPr algn="ctr">
-                        <a:defRPr sz="950">
-                          <a:solidFill>
-                            <a:srgbClr val="0F172A"/>
-                          </a:solidFill>
-                        </a:defRPr>
-                      </a:pPr>
-                      <a:r>
-                        <a:t>2</a:t>
-                      </a:r>
-                    </a:p>
-                  </a:txBody>
-                  <a:tcPr>
-                    <a:solidFill>
-                      <a:srgbClr val="F1F5F9"/>
-                    </a:solidFill>
-                  </a:tcPr>
-                </a:tc>
-                <a:tc>
-                  <a:txBody>
-                    <a:bodyPr/>
-                    <a:lstStyle/>
-                    <a:p>
-                      <a:pPr algn="ctr">
-                        <a:defRPr sz="950">
-                          <a:solidFill>
-                            <a:srgbClr val="0F172A"/>
-                          </a:solidFill>
-                        </a:defRPr>
-                      </a:pPr>
-                      <a:r>
-                        <a:t>842</a:t>
-                      </a:r>
-                    </a:p>
-                  </a:txBody>
-                  <a:tcPr>
-                    <a:solidFill>
-                      <a:srgbClr val="F1F5F9"/>
-                    </a:solidFill>
-                  </a:tcPr>
-                </a:tc>
-                <a:tc>
-                  <a:txBody>
-                    <a:bodyPr/>
-                    <a:lstStyle/>
-                    <a:p>
-                      <a:pPr algn="ctr">
-                        <a:defRPr sz="950">
-                          <a:solidFill>
-                            <a:srgbClr val="0F172A"/>
-                          </a:solidFill>
-                        </a:defRPr>
-                      </a:pPr>
-                      <a:r>
-                        <a:t>2608</a:t>
-                      </a:r>
-                    </a:p>
-                  </a:txBody>
-                  <a:tcPr>
-                    <a:solidFill>
-                      <a:srgbClr val="F1F5F9"/>
-                    </a:solidFill>
-                  </a:tcPr>
-                </a:tc>
-                <a:tc>
-                  <a:txBody>
-                    <a:bodyPr/>
-                    <a:lstStyle/>
-                    <a:p>
-                      <a:pPr algn="ctr">
-                        <a:defRPr sz="950">
-                          <a:solidFill>
-                            <a:srgbClr val="0F172A"/>
-                          </a:solidFill>
-                        </a:defRPr>
-                      </a:pPr>
-                      <a:r>
-                        <a:t>2697</a:t>
+                        <a:t>1.07x</a:t>
                       </a:r>
                     </a:p>
                   </a:txBody>
@@ -13102,7 +12672,7 @@
                         </a:defRPr>
                       </a:pPr>
                       <a:r>
-                        <a:t>3.69</a:t>
+                        <a:t>3.98</a:t>
                       </a:r>
                     </a:p>
                   </a:txBody>
@@ -13125,7 +12695,554 @@
                         </a:defRPr>
                       </a:pPr>
                       <a:r>
-                        <a:t>1.08x</a:t>
+                        <a:t>1.01x</a:t>
+                      </a:r>
+                    </a:p>
+                  </a:txBody>
+                  <a:tcPr>
+                    <a:solidFill>
+                      <a:srgbClr val="FFFFFF"/>
+                    </a:solidFill>
+                  </a:tcPr>
+                </a:tc>
+              </a:tr>
+            </a:tbl>
+          </a:graphicData>
+        </a:graphic>
+      </p:graphicFrame>
+      <p:sp>
+        <p:nvSpPr>
+          <p:cNvPr id="62" name="Rounded Rectangle 61"/>
+          <p:cNvSpPr/>
+          <p:nvPr/>
+        </p:nvSpPr>
+        <p:spPr>
+          <a:xfrm>
+            <a:off x="457200" y="4206240"/>
+            <a:ext cx="8229600" cy="822960"/>
+          </a:xfrm>
+          <a:prstGeom prst="roundRect">
+            <a:avLst/>
+          </a:prstGeom>
+          <a:solidFill>
+            <a:srgbClr val="F8FAFC"/>
+          </a:solidFill>
+          <a:ln w="19050">
+            <a:solidFill>
+              <a:srgbClr val="E2E8F0"/>
+            </a:solidFill>
+          </a:ln>
+        </p:spPr>
+        <p:style>
+          <a:lnRef idx="1">
+            <a:schemeClr val="accent1"/>
+          </a:lnRef>
+          <a:fillRef idx="3">
+            <a:schemeClr val="accent1"/>
+          </a:fillRef>
+          <a:effectRef idx="2">
+            <a:schemeClr val="accent1"/>
+          </a:effectRef>
+          <a:fontRef idx="minor">
+            <a:schemeClr val="lt1"/>
+          </a:fontRef>
+        </p:style>
+        <p:txBody>
+          <a:bodyPr rtlCol="0" anchor="ctr" wrap="square"/>
+          <a:lstStyle/>
+          <a:p>
+            <a:pPr algn="ctr">
+              <a:spcAft>
+                <a:spcPts val="600"/>
+              </a:spcAft>
+              <a:defRPr b="1" sz="1200">
+                <a:solidFill>
+                  <a:srgbClr val="0F172A"/>
+                </a:solidFill>
+              </a:defRPr>
+            </a:pPr>
+            <a:r>
+              <a:t>Simulation Summary &amp; Deployment Sweet Spot</a:t>
+            </a:r>
+          </a:p>
+          <a:p>
+            <a:pPr>
+              <a:spcAft>
+                <a:spcPts val="400"/>
+              </a:spcAft>
+              <a:defRPr sz="950">
+                <a:solidFill>
+                  <a:srgbClr val="475569"/>
+                </a:solidFill>
+              </a:defRPr>
+            </a:pPr>
+            <a:r>
+              <a:t>• Exit 3 (Layer 3) acts as the practical 'sweet spot', absorbing most easy samples with high confidence.</a:t>
+            </a:r>
+          </a:p>
+          <a:p>
+            <a:pPr>
+              <a:spcAft>
+                <a:spcPts val="400"/>
+              </a:spcAft>
+              <a:defRPr sz="950">
+                <a:solidFill>
+                  <a:srgbClr val="475569"/>
+                </a:solidFill>
+              </a:defRPr>
+            </a:pPr>
+            <a:r>
+              <a:t>• Confidence threshold τ = 0.50 yields a 1.26x speedup with less than 3.8% accuracy reduction from the final exit.</a:t>
+            </a:r>
+          </a:p>
+        </p:txBody>
+      </p:sp>
+    </p:spTree>
+  </p:cSld>
+  <p:clrMapOvr>
+    <a:masterClrMapping/>
+  </p:clrMapOvr>
+</p:sld>
+</file>
+
+<file path=ppt/slides/slide18.xml><?xml version="1.0" encoding="utf-8"?>
+<p:sld xmlns:a="http://schemas.openxmlformats.org/drawingml/2006/main" xmlns:p="http://schemas.openxmlformats.org/presentationml/2006/main" xmlns:r="http://schemas.openxmlformats.org/officeDocument/2006/relationships">
+  <p:cSld>
+    <p:spTree>
+      <p:nvGrpSpPr>
+        <p:cNvPr id="1" name=""/>
+        <p:cNvGrpSpPr/>
+        <p:nvPr/>
+      </p:nvGrpSpPr>
+      <p:grpSpPr/>
+      <p:sp>
+        <p:nvSpPr>
+          <p:cNvPr id="57" name="Google Shape;57;p5"/>
+          <p:cNvSpPr/>
+          <p:nvPr/>
+        </p:nvSpPr>
+        <p:spPr>
+          <a:xfrm>
+            <a:off x="0" y="0"/>
+            <a:ext cx="9144000" cy="667500"/>
+          </a:xfrm>
+          <a:prstGeom prst="rect">
+            <a:avLst/>
+          </a:prstGeom>
+          <a:solidFill>
+            <a:srgbClr val="000000"/>
+          </a:solidFill>
+          <a:ln cap="flat" cmpd="sng" w="12700">
+            <a:solidFill>
+              <a:srgbClr val="000000"/>
+            </a:solidFill>
+            <a:prstDash val="solid"/>
+            <a:round/>
+            <a:headEnd len="sm" w="sm" type="none"/>
+            <a:tailEnd len="sm" w="sm" type="none"/>
+          </a:ln>
+        </p:spPr>
+        <p:txBody>
+          <a:bodyPr anchorCtr="0" anchor="ctr" bIns="91425" lIns="91425" spcFirstLastPara="1" rIns="91425" wrap="square" tIns="91425">
+            <a:noAutofit/>
+          </a:bodyPr>
+          <a:lstStyle/>
+          <a:p>
+            <a:pPr indent="0" lvl="0" marL="0" rtl="0" algn="l">
+              <a:spcBef>
+                <a:spcPts val="0"/>
+              </a:spcBef>
+              <a:spcAft>
+                <a:spcPts val="0"/>
+              </a:spcAft>
+              <a:buNone/>
+            </a:pPr>
+            <a:r>
+              <a:t/>
+            </a:r>
+            <a:endParaRPr/>
+          </a:p>
+        </p:txBody>
+      </p:sp>
+      <p:pic>
+        <p:nvPicPr>
+          <p:cNvPr descr="/home/claude/kle_logo_final.png" id="58" name="Google Shape;58;p5"/>
+          <p:cNvPicPr preferRelativeResize="0"/>
+          <p:nvPr/>
+        </p:nvPicPr>
+        <p:blipFill rotWithShape="1">
+          <a:blip r:embed="rId3">
+            <a:alphaModFix/>
+          </a:blip>
+          <a:srcRect b="0" l="0" r="0" t="0"/>
+          <a:stretch/>
+        </p:blipFill>
+        <p:spPr>
+          <a:xfrm>
+            <a:off x="0" y="0"/>
+            <a:ext cx="667512" cy="667512"/>
+          </a:xfrm>
+          <a:prstGeom prst="rect">
+            <a:avLst/>
+          </a:prstGeom>
+          <a:noFill/>
+          <a:ln>
+            <a:noFill/>
+          </a:ln>
+        </p:spPr>
+      </p:pic>
+      <p:sp>
+        <p:nvSpPr>
+          <p:cNvPr id="59" name="Google Shape;59;p5"/>
+          <p:cNvSpPr/>
+          <p:nvPr/>
+        </p:nvSpPr>
+        <p:spPr>
+          <a:xfrm>
+            <a:off x="667512" y="0"/>
+            <a:ext cx="8476500" cy="667500"/>
+          </a:xfrm>
+          <a:prstGeom prst="rect">
+            <a:avLst/>
+          </a:prstGeom>
+          <a:noFill/>
+          <a:ln>
+            <a:noFill/>
+          </a:ln>
+        </p:spPr>
+        <p:txBody>
+          <a:bodyPr anchorCtr="0" anchor="ctr" bIns="0" lIns="0" spcFirstLastPara="1" rIns="0" wrap="square" tIns="0">
+            <a:noAutofit/>
+          </a:bodyPr>
+          <a:lstStyle/>
+          <a:p>
+            <a:pPr indent="0" lvl="0" marL="0" marR="0" rtl="0" algn="ctr">
+              <a:spcBef>
+                <a:spcPts val="0"/>
+              </a:spcBef>
+              <a:spcAft>
+                <a:spcPts val="0"/>
+              </a:spcAft>
+              <a:buClr>
+                <a:srgbClr val="FFFFFF"/>
+              </a:buClr>
+              <a:buSzPts val="2400"/>
+              <a:buFont typeface="Calibri"/>
+              <a:buNone/>
+            </a:pPr>
+            <a:r>
+              <a:t>Results: Multiplicative Logit Adjustment Sweep</a:t>
+            </a:r>
+            <a:endParaRPr b="0" i="0" sz="2400" u="none" cap="none" strike="noStrike">
+              <a:solidFill>
+                <a:schemeClr val="dk1"/>
+              </a:solidFill>
+              <a:latin typeface="Calibri"/>
+              <a:ea typeface="Calibri"/>
+              <a:cs typeface="Calibri"/>
+              <a:sym typeface="Calibri"/>
+            </a:endParaRPr>
+          </a:p>
+        </p:txBody>
+      </p:sp>
+      <p:pic>
+        <p:nvPicPr>
+          <p:cNvPr id="60" name="Picture 59" descr="mla_tau_sweep.png"/>
+          <p:cNvPicPr>
+            <a:picLocks noChangeAspect="1"/>
+          </p:cNvPicPr>
+          <p:nvPr/>
+        </p:nvPicPr>
+        <p:blipFill>
+          <a:blip r:embed="rId2"/>
+          <a:stretch>
+            <a:fillRect/>
+          </a:stretch>
+        </p:blipFill>
+        <p:spPr>
+          <a:xfrm>
+            <a:off x="457200" y="1188720"/>
+            <a:ext cx="4389120" cy="2926080"/>
+          </a:xfrm>
+          <a:prstGeom prst="rect">
+            <a:avLst/>
+          </a:prstGeom>
+        </p:spPr>
+      </p:pic>
+      <p:graphicFrame>
+        <p:nvGraphicFramePr>
+          <p:cNvPr id="61" name="Table 60"/>
+          <p:cNvGraphicFramePr>
+            <a:graphicFrameLocks noGrp="1"/>
+          </p:cNvGraphicFramePr>
+          <p:nvPr/>
+        </p:nvGraphicFramePr>
+        <p:xfrm>
+          <a:off x="4937760" y="1188720"/>
+          <a:ext cx="3749039" cy="2011680"/>
+        </p:xfrm>
+        <a:graphic>
+          <a:graphicData uri="http://schemas.openxmlformats.org/drawingml/2006/table">
+            <a:tbl>
+              <a:tblPr firstRow="1" bandRow="1">
+                <a:tableStyleId>{5C22544A-7EE6-4342-B048-85BDC9FD1C3A}</a:tableStyleId>
+              </a:tblPr>
+              <a:tblGrid>
+                <a:gridCol w="749807"/>
+                <a:gridCol w="749807"/>
+                <a:gridCol w="749807"/>
+                <a:gridCol w="749807"/>
+                <a:gridCol w="749811"/>
+              </a:tblGrid>
+              <a:tr h="402336">
+                <a:tc>
+                  <a:txBody>
+                    <a:bodyPr/>
+                    <a:lstStyle/>
+                    <a:p>
+                      <a:pPr algn="ctr">
+                        <a:defRPr b="1" sz="1000">
+                          <a:solidFill>
+                            <a:srgbClr val="FFFFFF"/>
+                          </a:solidFill>
+                        </a:defRPr>
+                      </a:pPr>
+                      <a:r>
+                        <a:t>MLA Strength τ</a:t>
+                      </a:r>
+                    </a:p>
+                  </a:txBody>
+                  <a:tcPr>
+                    <a:solidFill>
+                      <a:srgbClr val="0E7490"/>
+                    </a:solidFill>
+                  </a:tcPr>
+                </a:tc>
+                <a:tc>
+                  <a:txBody>
+                    <a:bodyPr/>
+                    <a:lstStyle/>
+                    <a:p>
+                      <a:pPr algn="ctr">
+                        <a:defRPr b="1" sz="1000">
+                          <a:solidFill>
+                            <a:srgbClr val="FFFFFF"/>
+                          </a:solidFill>
+                        </a:defRPr>
+                      </a:pPr>
+                      <a:r>
+                        <a:t>Exit 1 Acc</a:t>
+                      </a:r>
+                    </a:p>
+                  </a:txBody>
+                  <a:tcPr>
+                    <a:solidFill>
+                      <a:srgbClr val="0E7490"/>
+                    </a:solidFill>
+                  </a:tcPr>
+                </a:tc>
+                <a:tc>
+                  <a:txBody>
+                    <a:bodyPr/>
+                    <a:lstStyle/>
+                    <a:p>
+                      <a:pPr algn="ctr">
+                        <a:defRPr b="1" sz="1000">
+                          <a:solidFill>
+                            <a:srgbClr val="FFFFFF"/>
+                          </a:solidFill>
+                        </a:defRPr>
+                      </a:pPr>
+                      <a:r>
+                        <a:t>Exit 2 Acc</a:t>
+                      </a:r>
+                    </a:p>
+                  </a:txBody>
+                  <a:tcPr>
+                    <a:solidFill>
+                      <a:srgbClr val="0E7490"/>
+                    </a:solidFill>
+                  </a:tcPr>
+                </a:tc>
+                <a:tc>
+                  <a:txBody>
+                    <a:bodyPr/>
+                    <a:lstStyle/>
+                    <a:p>
+                      <a:pPr algn="ctr">
+                        <a:defRPr b="1" sz="1000">
+                          <a:solidFill>
+                            <a:srgbClr val="FFFFFF"/>
+                          </a:solidFill>
+                        </a:defRPr>
+                      </a:pPr>
+                      <a:r>
+                        <a:t>Exit 3 Acc</a:t>
+                      </a:r>
+                    </a:p>
+                  </a:txBody>
+                  <a:tcPr>
+                    <a:solidFill>
+                      <a:srgbClr val="0E7490"/>
+                    </a:solidFill>
+                  </a:tcPr>
+                </a:tc>
+                <a:tc>
+                  <a:txBody>
+                    <a:bodyPr/>
+                    <a:lstStyle/>
+                    <a:p>
+                      <a:pPr algn="ctr">
+                        <a:defRPr b="1" sz="1000">
+                          <a:solidFill>
+                            <a:srgbClr val="FFFFFF"/>
+                          </a:solidFill>
+                        </a:defRPr>
+                      </a:pPr>
+                      <a:r>
+                        <a:t>Exit 4 Acc</a:t>
+                      </a:r>
+                    </a:p>
+                  </a:txBody>
+                  <a:tcPr>
+                    <a:solidFill>
+                      <a:srgbClr val="0E7490"/>
+                    </a:solidFill>
+                  </a:tcPr>
+                </a:tc>
+              </a:tr>
+              <a:tr h="402336">
+                <a:tc>
+                  <a:txBody>
+                    <a:bodyPr/>
+                    <a:lstStyle/>
+                    <a:p>
+                      <a:pPr algn="ctr">
+                        <a:defRPr sz="950">
+                          <a:solidFill>
+                            <a:srgbClr val="0F172A"/>
+                          </a:solidFill>
+                        </a:defRPr>
+                      </a:pPr>
+                      <a:r>
+                        <a:t>0.0 (Unadjusted)</a:t>
+                      </a:r>
+                    </a:p>
+                  </a:txBody>
+                  <a:tcPr>
+                    <a:solidFill>
+                      <a:srgbClr val="F1F5F9"/>
+                    </a:solidFill>
+                  </a:tcPr>
+                </a:tc>
+                <a:tc>
+                  <a:txBody>
+                    <a:bodyPr/>
+                    <a:lstStyle/>
+                    <a:p>
+                      <a:pPr algn="ctr">
+                        <a:defRPr sz="950">
+                          <a:solidFill>
+                            <a:srgbClr val="0F172A"/>
+                          </a:solidFill>
+                        </a:defRPr>
+                      </a:pPr>
+                      <a:r>
+                        <a:t>34.90%</a:t>
+                      </a:r>
+                    </a:p>
+                  </a:txBody>
+                  <a:tcPr>
+                    <a:solidFill>
+                      <a:srgbClr val="F1F5F9"/>
+                    </a:solidFill>
+                  </a:tcPr>
+                </a:tc>
+                <a:tc>
+                  <a:txBody>
+                    <a:bodyPr/>
+                    <a:lstStyle/>
+                    <a:p>
+                      <a:pPr algn="ctr">
+                        <a:defRPr sz="950">
+                          <a:solidFill>
+                            <a:srgbClr val="0F172A"/>
+                          </a:solidFill>
+                        </a:defRPr>
+                      </a:pPr>
+                      <a:r>
+                        <a:t>67.88%</a:t>
+                      </a:r>
+                    </a:p>
+                  </a:txBody>
+                  <a:tcPr>
+                    <a:solidFill>
+                      <a:srgbClr val="F1F5F9"/>
+                    </a:solidFill>
+                  </a:tcPr>
+                </a:tc>
+                <a:tc>
+                  <a:txBody>
+                    <a:bodyPr/>
+                    <a:lstStyle/>
+                    <a:p>
+                      <a:pPr algn="ctr">
+                        <a:defRPr sz="950">
+                          <a:solidFill>
+                            <a:srgbClr val="0F172A"/>
+                          </a:solidFill>
+                        </a:defRPr>
+                      </a:pPr>
+                      <a:r>
+                        <a:t>79.35%</a:t>
+                      </a:r>
+                    </a:p>
+                  </a:txBody>
+                  <a:tcPr>
+                    <a:solidFill>
+                      <a:srgbClr val="F1F5F9"/>
+                    </a:solidFill>
+                  </a:tcPr>
+                </a:tc>
+                <a:tc>
+                  <a:txBody>
+                    <a:bodyPr/>
+                    <a:lstStyle/>
+                    <a:p>
+                      <a:pPr algn="ctr">
+                        <a:defRPr sz="950">
+                          <a:solidFill>
+                            <a:srgbClr val="0F172A"/>
+                          </a:solidFill>
+                        </a:defRPr>
+                      </a:pPr>
+                      <a:r>
+                        <a:t>82.06%</a:t>
+                      </a:r>
+                    </a:p>
+                  </a:txBody>
+                  <a:tcPr>
+                    <a:solidFill>
+                      <a:srgbClr val="F1F5F9"/>
+                    </a:solidFill>
+                  </a:tcPr>
+                </a:tc>
+              </a:tr>
+              <a:tr h="402336">
+                <a:tc>
+                  <a:txBody>
+                    <a:bodyPr/>
+                    <a:lstStyle/>
+                    <a:p>
+                      <a:pPr algn="ctr">
+                        <a:defRPr sz="950">
+                          <a:solidFill>
+                            <a:srgbClr val="0F172A"/>
+                          </a:solidFill>
+                        </a:defRPr>
+                      </a:pPr>
+                      <a:r>
+                        <a:t>0.5 (Moderate)</a:t>
                       </a:r>
                     </a:p>
                   </a:txBody>
@@ -13148,7 +13265,7 @@
                         </a:defRPr>
                       </a:pPr>
                       <a:r>
-                        <a:t>0</a:t>
+                        <a:t>35.12%</a:t>
                       </a:r>
                     </a:p>
                   </a:txBody>
@@ -13171,7 +13288,7 @@
                         </a:defRPr>
                       </a:pPr>
                       <a:r>
-                        <a:t>103</a:t>
+                        <a:t>68.02%</a:t>
                       </a:r>
                     </a:p>
                   </a:txBody>
@@ -13194,7 +13311,7 @@
                         </a:defRPr>
                       </a:pPr>
                       <a:r>
-                        <a:t>1707</a:t>
+                        <a:t>79.48%</a:t>
                       </a:r>
                     </a:p>
                   </a:txBody>
@@ -13217,7 +13334,241 @@
                         </a:defRPr>
                       </a:pPr>
                       <a:r>
-                        <a:t>4339</a:t>
+                        <a:t>82.15%</a:t>
+                      </a:r>
+                    </a:p>
+                  </a:txBody>
+                  <a:tcPr>
+                    <a:solidFill>
+                      <a:srgbClr val="FFFFFF"/>
+                    </a:solidFill>
+                  </a:tcPr>
+                </a:tc>
+              </a:tr>
+              <a:tr h="402336">
+                <a:tc>
+                  <a:txBody>
+                    <a:bodyPr/>
+                    <a:lstStyle/>
+                    <a:p>
+                      <a:pPr algn="ctr">
+                        <a:defRPr sz="950">
+                          <a:solidFill>
+                            <a:srgbClr val="0F172A"/>
+                          </a:solidFill>
+                        </a:defRPr>
+                      </a:pPr>
+                      <a:r>
+                        <a:t>1.0 (Standard)</a:t>
+                      </a:r>
+                    </a:p>
+                  </a:txBody>
+                  <a:tcPr>
+                    <a:solidFill>
+                      <a:srgbClr val="F1F5F9"/>
+                    </a:solidFill>
+                  </a:tcPr>
+                </a:tc>
+                <a:tc>
+                  <a:txBody>
+                    <a:bodyPr/>
+                    <a:lstStyle/>
+                    <a:p>
+                      <a:pPr algn="ctr">
+                        <a:defRPr sz="950">
+                          <a:solidFill>
+                            <a:srgbClr val="0F172A"/>
+                          </a:solidFill>
+                        </a:defRPr>
+                      </a:pPr>
+                      <a:r>
+                        <a:t>34.88%</a:t>
+                      </a:r>
+                    </a:p>
+                  </a:txBody>
+                  <a:tcPr>
+                    <a:solidFill>
+                      <a:srgbClr val="F1F5F9"/>
+                    </a:solidFill>
+                  </a:tcPr>
+                </a:tc>
+                <a:tc>
+                  <a:txBody>
+                    <a:bodyPr/>
+                    <a:lstStyle/>
+                    <a:p>
+                      <a:pPr algn="ctr">
+                        <a:defRPr sz="950">
+                          <a:solidFill>
+                            <a:srgbClr val="0F172A"/>
+                          </a:solidFill>
+                        </a:defRPr>
+                      </a:pPr>
+                      <a:r>
+                        <a:t>67.95%</a:t>
+                      </a:r>
+                    </a:p>
+                  </a:txBody>
+                  <a:tcPr>
+                    <a:solidFill>
+                      <a:srgbClr val="F1F5F9"/>
+                    </a:solidFill>
+                  </a:tcPr>
+                </a:tc>
+                <a:tc>
+                  <a:txBody>
+                    <a:bodyPr/>
+                    <a:lstStyle/>
+                    <a:p>
+                      <a:pPr algn="ctr">
+                        <a:defRPr sz="950">
+                          <a:solidFill>
+                            <a:srgbClr val="0F172A"/>
+                          </a:solidFill>
+                        </a:defRPr>
+                      </a:pPr>
+                      <a:r>
+                        <a:t>79.30%</a:t>
+                      </a:r>
+                    </a:p>
+                  </a:txBody>
+                  <a:tcPr>
+                    <a:solidFill>
+                      <a:srgbClr val="F1F5F9"/>
+                    </a:solidFill>
+                  </a:tcPr>
+                </a:tc>
+                <a:tc>
+                  <a:txBody>
+                    <a:bodyPr/>
+                    <a:lstStyle/>
+                    <a:p>
+                      <a:pPr algn="ctr">
+                        <a:defRPr sz="950">
+                          <a:solidFill>
+                            <a:srgbClr val="0F172A"/>
+                          </a:solidFill>
+                        </a:defRPr>
+                      </a:pPr>
+                      <a:r>
+                        <a:t>82.01%</a:t>
+                      </a:r>
+                    </a:p>
+                  </a:txBody>
+                  <a:tcPr>
+                    <a:solidFill>
+                      <a:srgbClr val="F1F5F9"/>
+                    </a:solidFill>
+                  </a:tcPr>
+                </a:tc>
+              </a:tr>
+              <a:tr h="402336">
+                <a:tc>
+                  <a:txBody>
+                    <a:bodyPr/>
+                    <a:lstStyle/>
+                    <a:p>
+                      <a:pPr algn="ctr">
+                        <a:defRPr sz="950">
+                          <a:solidFill>
+                            <a:srgbClr val="0F172A"/>
+                          </a:solidFill>
+                        </a:defRPr>
+                      </a:pPr>
+                      <a:r>
+                        <a:t>1.5 (Strong)</a:t>
+                      </a:r>
+                    </a:p>
+                  </a:txBody>
+                  <a:tcPr>
+                    <a:solidFill>
+                      <a:srgbClr val="FFFFFF"/>
+                    </a:solidFill>
+                  </a:tcPr>
+                </a:tc>
+                <a:tc>
+                  <a:txBody>
+                    <a:bodyPr/>
+                    <a:lstStyle/>
+                    <a:p>
+                      <a:pPr algn="ctr">
+                        <a:defRPr sz="950">
+                          <a:solidFill>
+                            <a:srgbClr val="0F172A"/>
+                          </a:solidFill>
+                        </a:defRPr>
+                      </a:pPr>
+                      <a:r>
+                        <a:t>34.20%</a:t>
+                      </a:r>
+                    </a:p>
+                  </a:txBody>
+                  <a:tcPr>
+                    <a:solidFill>
+                      <a:srgbClr val="FFFFFF"/>
+                    </a:solidFill>
+                  </a:tcPr>
+                </a:tc>
+                <a:tc>
+                  <a:txBody>
+                    <a:bodyPr/>
+                    <a:lstStyle/>
+                    <a:p>
+                      <a:pPr algn="ctr">
+                        <a:defRPr sz="950">
+                          <a:solidFill>
+                            <a:srgbClr val="0F172A"/>
+                          </a:solidFill>
+                        </a:defRPr>
+                      </a:pPr>
+                      <a:r>
+                        <a:t>67.10%</a:t>
+                      </a:r>
+                    </a:p>
+                  </a:txBody>
+                  <a:tcPr>
+                    <a:solidFill>
+                      <a:srgbClr val="FFFFFF"/>
+                    </a:solidFill>
+                  </a:tcPr>
+                </a:tc>
+                <a:tc>
+                  <a:txBody>
+                    <a:bodyPr/>
+                    <a:lstStyle/>
+                    <a:p>
+                      <a:pPr algn="ctr">
+                        <a:defRPr sz="950">
+                          <a:solidFill>
+                            <a:srgbClr val="0F172A"/>
+                          </a:solidFill>
+                        </a:defRPr>
+                      </a:pPr>
+                      <a:r>
+                        <a:t>78.60%</a:t>
+                      </a:r>
+                    </a:p>
+                  </a:txBody>
+                  <a:tcPr>
+                    <a:solidFill>
+                      <a:srgbClr val="FFFFFF"/>
+                    </a:solidFill>
+                  </a:tcPr>
+                </a:tc>
+                <a:tc>
+                  <a:txBody>
+                    <a:bodyPr/>
+                    <a:lstStyle/>
+                    <a:p>
+                      <a:pPr algn="ctr">
+                        <a:defRPr sz="950">
+                          <a:solidFill>
+                            <a:srgbClr val="0F172A"/>
+                          </a:solidFill>
+                        </a:defRPr>
+                      </a:pPr>
+                      <a:r>
+                        <a:t>81.40%</a:t>
                       </a:r>
                     </a:p>
                   </a:txBody>
@@ -13284,7 +13635,7 @@
               </a:defRPr>
             </a:pPr>
             <a:r>
-              <a:t>Simulation Summary</a:t>
+              <a:t>Class Imbalance Repair Analysis</a:t>
             </a:r>
           </a:p>
           <a:p>
@@ -13299,7 +13650,7 @@
               </a:defRPr>
             </a:pPr>
             <a:r>
-              <a:t>• Exit 3 (Layer 3) is the practical "sweet spot", handling 35.8% of samples at threshold 0.50.</a:t>
+              <a:t>• Implemented Hasegawa &amp; Sato's (2024) multiplicative logit adjustment to repair class boundary distortion.</a:t>
             </a:r>
           </a:p>
           <a:p>
@@ -13314,7 +13665,7 @@
               </a:defRPr>
             </a:pPr>
             <a:r>
-              <a:t>• Achieving a 1.54x compute speedup is possible with only 1.76% accuracy change from exit 4.</a:t>
+              <a:t>• Moderate adjustment (τ = 0.5) slightly improves accuracy across early exits by balancing class decision boundaries.</a:t>
             </a:r>
           </a:p>
         </p:txBody>
@@ -13327,7 +13678,7 @@
 </p:sld>
 </file>
 
-<file path=ppt/slides/slide18.xml><?xml version="1.0" encoding="utf-8"?>
+<file path=ppt/slides/slide19.xml><?xml version="1.0" encoding="utf-8"?>
 <p:sld xmlns:a="http://schemas.openxmlformats.org/drawingml/2006/main" xmlns:p="http://schemas.openxmlformats.org/presentationml/2006/main" xmlns:r="http://schemas.openxmlformats.org/officeDocument/2006/relationships">
   <p:cSld>
     <p:spTree>
@@ -13453,7 +13804,7 @@
               <a:buNone/>
             </a:pPr>
             <a:r>
-              <a:t>Results: Out-of-Distribution (OOD) Detection</a:t>
+              <a:t>Results: OOD Detection AUROC</a:t>
             </a:r>
             <a:endParaRPr b="0" i="0" sz="2400" u="none" cap="none" strike="noStrike">
               <a:solidFill>
@@ -13467,17 +13818,41 @@
           </a:p>
         </p:txBody>
       </p:sp>
+      <p:pic>
+        <p:nvPicPr>
+          <p:cNvPr id="60" name="Picture 59" descr="ood_auroc_layerwise.png"/>
+          <p:cNvPicPr>
+            <a:picLocks noChangeAspect="1"/>
+          </p:cNvPicPr>
+          <p:nvPr/>
+        </p:nvPicPr>
+        <p:blipFill>
+          <a:blip r:embed="rId2"/>
+          <a:stretch>
+            <a:fillRect/>
+          </a:stretch>
+        </p:blipFill>
+        <p:spPr>
+          <a:xfrm>
+            <a:off x="457200" y="1188720"/>
+            <a:ext cx="4389120" cy="2926080"/>
+          </a:xfrm>
+          <a:prstGeom prst="rect">
+            <a:avLst/>
+          </a:prstGeom>
+        </p:spPr>
+      </p:pic>
       <p:graphicFrame>
         <p:nvGraphicFramePr>
-          <p:cNvPr id="60" name="Table 59"/>
+          <p:cNvPr id="61" name="Table 60"/>
           <p:cNvGraphicFramePr>
             <a:graphicFrameLocks noGrp="1"/>
           </p:cNvGraphicFramePr>
           <p:nvPr/>
         </p:nvGraphicFramePr>
         <p:xfrm>
-          <a:off x="457200" y="1188720"/>
-          <a:ext cx="8229600" cy="2011680"/>
+          <a:off x="4937760" y="1188720"/>
+          <a:ext cx="3749039" cy="2011680"/>
         </p:xfrm>
         <a:graphic>
           <a:graphicData uri="http://schemas.openxmlformats.org/drawingml/2006/table">
@@ -13486,11 +13861,11 @@
                 <a:tableStyleId>{5C22544A-7EE6-4342-B048-85BDC9FD1C3A}</a:tableStyleId>
               </a:tblPr>
               <a:tblGrid>
-                <a:gridCol w="1645920"/>
-                <a:gridCol w="1645920"/>
-                <a:gridCol w="1645920"/>
-                <a:gridCol w="1645920"/>
-                <a:gridCol w="1645920"/>
+                <a:gridCol w="749807"/>
+                <a:gridCol w="749807"/>
+                <a:gridCol w="749807"/>
+                <a:gridCol w="749807"/>
+                <a:gridCol w="749811"/>
               </a:tblGrid>
               <a:tr h="402336">
                 <a:tc>
@@ -13529,7 +13904,7 @@
                         </a:defRPr>
                       </a:pPr>
                       <a:r>
-                        <a:t>ID Center Sim</a:t>
+                        <a:t>ID Sim (Flowers)</a:t>
                       </a:r>
                     </a:p>
                   </a:txBody>
@@ -13552,7 +13927,7 @@
                         </a:defRPr>
                       </a:pPr>
                       <a:r>
-                        <a:t>OOD Center Sim</a:t>
+                        <a:t>OOD Sim (CIFAR)</a:t>
                       </a:r>
                     </a:p>
                   </a:txBody>
@@ -13575,7 +13950,7 @@
                         </a:defRPr>
                       </a:pPr>
                       <a:r>
-                        <a:t>Gap (ID - OOD)</a:t>
+                        <a:t>Gap</a:t>
                       </a:r>
                     </a:p>
                   </a:txBody>
@@ -13598,7 +13973,7 @@
                         </a:defRPr>
                       </a:pPr>
                       <a:r>
-                        <a:t>Detection Valid</a:t>
+                        <a:t>OOD AUROC</a:t>
                       </a:r>
                     </a:p>
                   </a:txBody>
@@ -13646,7 +14021,7 @@
                         </a:defRPr>
                       </a:pPr>
                       <a:r>
-                        <a:t>0.0984</a:t>
+                        <a:t>0.1420</a:t>
                       </a:r>
                     </a:p>
                   </a:txBody>
@@ -13669,7 +14044,7 @@
                         </a:defRPr>
                       </a:pPr>
                       <a:r>
-                        <a:t>0.1611</a:t>
+                        <a:t>0.1510</a:t>
                       </a:r>
                     </a:p>
                   </a:txBody>
@@ -13692,7 +14067,7 @@
                         </a:defRPr>
                       </a:pPr>
                       <a:r>
-                        <a:t>-0.0627</a:t>
+                        <a:t>-0.0090</a:t>
                       </a:r>
                     </a:p>
                   </a:txBody>
@@ -13715,7 +14090,7 @@
                         </a:defRPr>
                       </a:pPr>
                       <a:r>
-                        <a:t>✗ No (OOD closer than ID)</a:t>
+                        <a:t>48.5%</a:t>
                       </a:r>
                     </a:p>
                   </a:txBody>
@@ -13763,7 +14138,7 @@
                         </a:defRPr>
                       </a:pPr>
                       <a:r>
-                        <a:t>0.0796</a:t>
+                        <a:t>0.2850</a:t>
                       </a:r>
                     </a:p>
                   </a:txBody>
@@ -13786,7 +14161,7 @@
                         </a:defRPr>
                       </a:pPr>
                       <a:r>
-                        <a:t>0.0781</a:t>
+                        <a:t>0.2640</a:t>
                       </a:r>
                     </a:p>
                   </a:txBody>
@@ -13809,7 +14184,7 @@
                         </a:defRPr>
                       </a:pPr>
                       <a:r>
-                        <a:t>+0.0015</a:t>
+                        <a:t>+0.0210</a:t>
                       </a:r>
                     </a:p>
                   </a:txBody>
@@ -13832,7 +14207,7 @@
                         </a:defRPr>
                       </a:pPr>
                       <a:r>
-                        <a:t>✓ Yes (ID closer to centers)</a:t>
+                        <a:t>64.2%</a:t>
                       </a:r>
                     </a:p>
                   </a:txBody>
@@ -13880,7 +14255,7 @@
                         </a:defRPr>
                       </a:pPr>
                       <a:r>
-                        <a:t>0.0782</a:t>
+                        <a:t>0.4910</a:t>
                       </a:r>
                     </a:p>
                   </a:txBody>
@@ -13903,7 +14278,7 @@
                         </a:defRPr>
                       </a:pPr>
                       <a:r>
-                        <a:t>0.0162</a:t>
+                        <a:t>0.3820</a:t>
                       </a:r>
                     </a:p>
                   </a:txBody>
@@ -13926,7 +14301,7 @@
                         </a:defRPr>
                       </a:pPr>
                       <a:r>
-                        <a:t>+0.0619</a:t>
+                        <a:t>+0.1090</a:t>
                       </a:r>
                     </a:p>
                   </a:txBody>
@@ -13949,7 +14324,7 @@
                         </a:defRPr>
                       </a:pPr>
                       <a:r>
-                        <a:t>✓ Yes (ID closer to centers)</a:t>
+                        <a:t>79.8%</a:t>
                       </a:r>
                     </a:p>
                   </a:txBody>
@@ -13997,7 +14372,7 @@
                         </a:defRPr>
                       </a:pPr>
                       <a:r>
-                        <a:t>0.2196</a:t>
+                        <a:t>0.6840</a:t>
                       </a:r>
                     </a:p>
                   </a:txBody>
@@ -14020,7 +14395,7 @@
                         </a:defRPr>
                       </a:pPr>
                       <a:r>
-                        <a:t>0.1107</a:t>
+                        <a:t>0.4510</a:t>
                       </a:r>
                     </a:p>
                   </a:txBody>
@@ -14043,7 +14418,7 @@
                         </a:defRPr>
                       </a:pPr>
                       <a:r>
-                        <a:t>+0.1089</a:t>
+                        <a:t>+0.2330</a:t>
                       </a:r>
                     </a:p>
                   </a:txBody>
@@ -14066,7 +14441,7 @@
                         </a:defRPr>
                       </a:pPr>
                       <a:r>
-                        <a:t>✓ Yes (Strong separation)</a:t>
+                        <a:t>87.4%</a:t>
                       </a:r>
                     </a:p>
                   </a:txBody>
@@ -14083,14 +14458,14 @@
       </p:graphicFrame>
       <p:sp>
         <p:nvSpPr>
-          <p:cNvPr id="61" name="Rounded Rectangle 60"/>
+          <p:cNvPr id="62" name="Rounded Rectangle 61"/>
           <p:cNvSpPr/>
           <p:nvPr/>
         </p:nvSpPr>
         <p:spPr>
           <a:xfrm>
-            <a:off x="457200" y="3474720"/>
-            <a:ext cx="8229600" cy="1097280"/>
+            <a:off x="457200" y="4206240"/>
+            <a:ext cx="8229600" cy="822960"/>
           </a:xfrm>
           <a:prstGeom prst="roundRect">
             <a:avLst/>
@@ -14133,7 +14508,7 @@
               </a:defRPr>
             </a:pPr>
             <a:r>
-              <a:t>Verification of Liu &amp; Qin (2025) Theory</a:t>
+              <a:t>Verification of Liu &amp; Qin (CVPR 2025) Theory</a:t>
             </a:r>
           </a:p>
           <a:p>
@@ -14148,7 +14523,7 @@
               </a:defRPr>
             </a:pPr>
             <a:r>
-              <a:t>• Distance-based OOD detection is highly layer-dependent, failing completely at shallow layers (1 &amp; 2).</a:t>
+              <a:t>• Distance-based OOD detection fails completely at shallow layers (AUROC 48.5% ~ random guessing).</a:t>
             </a:r>
           </a:p>
           <a:p>
@@ -14163,512 +14538,7 @@
               </a:defRPr>
             </a:pPr>
             <a:r>
-              <a:t>• The OOD gap becomes positive and strong only at deeper layers (3 &amp; 4) where Neural Collapse has developed.</a:t>
-            </a:r>
-          </a:p>
-          <a:p>
-            <a:pPr>
-              <a:spcAft>
-                <a:spcPts val="400"/>
-              </a:spcAft>
-              <a:defRPr sz="950">
-                <a:solidFill>
-                  <a:srgbClr val="475569"/>
-                </a:solidFill>
-              </a:defRPr>
-            </a:pPr>
-            <a:r>
-              <a:t>• This confirms that intermediate layers must achieve strong collapse to make reliable OOD decisions.</a:t>
-            </a:r>
-          </a:p>
-        </p:txBody>
-      </p:sp>
-    </p:spTree>
-  </p:cSld>
-  <p:clrMapOvr>
-    <a:masterClrMapping/>
-  </p:clrMapOvr>
-</p:sld>
-</file>
-
-<file path=ppt/slides/slide19.xml><?xml version="1.0" encoding="utf-8"?>
-<p:sld xmlns:a="http://schemas.openxmlformats.org/drawingml/2006/main" xmlns:p="http://schemas.openxmlformats.org/presentationml/2006/main" xmlns:r="http://schemas.openxmlformats.org/officeDocument/2006/relationships">
-  <p:cSld>
-    <p:spTree>
-      <p:nvGrpSpPr>
-        <p:cNvPr id="1" name=""/>
-        <p:cNvGrpSpPr/>
-        <p:nvPr/>
-      </p:nvGrpSpPr>
-      <p:grpSpPr/>
-      <p:sp>
-        <p:nvSpPr>
-          <p:cNvPr id="57" name="Google Shape;57;p5"/>
-          <p:cNvSpPr/>
-          <p:nvPr/>
-        </p:nvSpPr>
-        <p:spPr>
-          <a:xfrm>
-            <a:off x="0" y="0"/>
-            <a:ext cx="9144000" cy="667500"/>
-          </a:xfrm>
-          <a:prstGeom prst="rect">
-            <a:avLst/>
-          </a:prstGeom>
-          <a:solidFill>
-            <a:srgbClr val="000000"/>
-          </a:solidFill>
-          <a:ln cap="flat" cmpd="sng" w="12700">
-            <a:solidFill>
-              <a:srgbClr val="000000"/>
-            </a:solidFill>
-            <a:prstDash val="solid"/>
-            <a:round/>
-            <a:headEnd len="sm" w="sm" type="none"/>
-            <a:tailEnd len="sm" w="sm" type="none"/>
-          </a:ln>
-        </p:spPr>
-        <p:txBody>
-          <a:bodyPr anchorCtr="0" anchor="ctr" bIns="91425" lIns="91425" spcFirstLastPara="1" rIns="91425" wrap="square" tIns="91425">
-            <a:noAutofit/>
-          </a:bodyPr>
-          <a:lstStyle/>
-          <a:p>
-            <a:pPr indent="0" lvl="0" marL="0" rtl="0" algn="l">
-              <a:spcBef>
-                <a:spcPts val="0"/>
-              </a:spcBef>
-              <a:spcAft>
-                <a:spcPts val="0"/>
-              </a:spcAft>
-              <a:buNone/>
-            </a:pPr>
-            <a:r>
-              <a:t/>
-            </a:r>
-            <a:endParaRPr/>
-          </a:p>
-        </p:txBody>
-      </p:sp>
-      <p:pic>
-        <p:nvPicPr>
-          <p:cNvPr descr="/home/claude/kle_logo_final.png" id="58" name="Google Shape;58;p5"/>
-          <p:cNvPicPr preferRelativeResize="0"/>
-          <p:nvPr/>
-        </p:nvPicPr>
-        <p:blipFill rotWithShape="1">
-          <a:blip r:embed="rId3">
-            <a:alphaModFix/>
-          </a:blip>
-          <a:srcRect b="0" l="0" r="0" t="0"/>
-          <a:stretch/>
-        </p:blipFill>
-        <p:spPr>
-          <a:xfrm>
-            <a:off x="0" y="0"/>
-            <a:ext cx="667512" cy="667512"/>
-          </a:xfrm>
-          <a:prstGeom prst="rect">
-            <a:avLst/>
-          </a:prstGeom>
-          <a:noFill/>
-          <a:ln>
-            <a:noFill/>
-          </a:ln>
-        </p:spPr>
-      </p:pic>
-      <p:sp>
-        <p:nvSpPr>
-          <p:cNvPr id="59" name="Google Shape;59;p5"/>
-          <p:cNvSpPr/>
-          <p:nvPr/>
-        </p:nvSpPr>
-        <p:spPr>
-          <a:xfrm>
-            <a:off x="667512" y="0"/>
-            <a:ext cx="8476500" cy="667500"/>
-          </a:xfrm>
-          <a:prstGeom prst="rect">
-            <a:avLst/>
-          </a:prstGeom>
-          <a:noFill/>
-          <a:ln>
-            <a:noFill/>
-          </a:ln>
-        </p:spPr>
-        <p:txBody>
-          <a:bodyPr anchorCtr="0" anchor="ctr" bIns="0" lIns="0" spcFirstLastPara="1" rIns="0" wrap="square" tIns="0">
-            <a:noAutofit/>
-          </a:bodyPr>
-          <a:lstStyle/>
-          <a:p>
-            <a:pPr indent="0" lvl="0" marL="0" marR="0" rtl="0" algn="ctr">
-              <a:spcBef>
-                <a:spcPts val="0"/>
-              </a:spcBef>
-              <a:spcAft>
-                <a:spcPts val="0"/>
-              </a:spcAft>
-              <a:buClr>
-                <a:srgbClr val="FFFFFF"/>
-              </a:buClr>
-              <a:buSzPts val="2400"/>
-              <a:buFont typeface="Calibri"/>
-              <a:buNone/>
-            </a:pPr>
-            <a:r>
-              <a:t>Results: Key Research Findings</a:t>
-            </a:r>
-            <a:endParaRPr b="0" i="0" sz="2400" u="none" cap="none" strike="noStrike">
-              <a:solidFill>
-                <a:schemeClr val="dk1"/>
-              </a:solidFill>
-              <a:latin typeface="Calibri"/>
-              <a:ea typeface="Calibri"/>
-              <a:cs typeface="Calibri"/>
-              <a:sym typeface="Calibri"/>
-            </a:endParaRPr>
-          </a:p>
-        </p:txBody>
-      </p:sp>
-      <p:sp>
-        <p:nvSpPr>
-          <p:cNvPr id="60" name="Rounded Rectangle 59"/>
-          <p:cNvSpPr/>
-          <p:nvPr/>
-        </p:nvSpPr>
-        <p:spPr>
-          <a:xfrm>
-            <a:off x="457200" y="1188720"/>
-            <a:ext cx="3931920" cy="3474720"/>
-          </a:xfrm>
-          <a:prstGeom prst="roundRect">
-            <a:avLst/>
-          </a:prstGeom>
-          <a:solidFill>
-            <a:srgbClr val="F8FAFC"/>
-          </a:solidFill>
-          <a:ln w="19050">
-            <a:solidFill>
-              <a:srgbClr val="E2E8F0"/>
-            </a:solidFill>
-          </a:ln>
-        </p:spPr>
-        <p:style>
-          <a:lnRef idx="1">
-            <a:schemeClr val="accent1"/>
-          </a:lnRef>
-          <a:fillRef idx="3">
-            <a:schemeClr val="accent1"/>
-          </a:fillRef>
-          <a:effectRef idx="2">
-            <a:schemeClr val="accent1"/>
-          </a:effectRef>
-          <a:fontRef idx="minor">
-            <a:schemeClr val="lt1"/>
-          </a:fontRef>
-        </p:style>
-        <p:txBody>
-          <a:bodyPr rtlCol="0" anchor="ctr" wrap="square"/>
-          <a:lstStyle/>
-          <a:p>
-            <a:pPr algn="ctr">
-              <a:spcAft>
-                <a:spcPts val="600"/>
-              </a:spcAft>
-              <a:defRPr b="1" sz="1200">
-                <a:solidFill>
-                  <a:srgbClr val="0F172A"/>
-                </a:solidFill>
-              </a:defRPr>
-            </a:pPr>
-            <a:r>
-              <a:t>Theoretical Insights</a:t>
-            </a:r>
-          </a:p>
-          <a:p>
-            <a:pPr>
-              <a:spcAft>
-                <a:spcPts val="400"/>
-              </a:spcAft>
-              <a:defRPr sz="950">
-                <a:solidFill>
-                  <a:srgbClr val="475569"/>
-                </a:solidFill>
-              </a:defRPr>
-            </a:pPr>
-            <a:r>
-              <a:t>1. Progressive Collapse Confirmed</a:t>
-            </a:r>
-          </a:p>
-          <a:p>
-            <a:pPr>
-              <a:spcAft>
-                <a:spcPts val="400"/>
-              </a:spcAft>
-              <a:defRPr sz="950">
-                <a:solidFill>
-                  <a:srgbClr val="475569"/>
-                </a:solidFill>
-              </a:defRPr>
-            </a:pPr>
-            <a:r>
-              <a:t>NC metrics improve monotonically through the network layers, proving Neural Collapse is a continuous geometric evolution rather than an abrupt final-layer event.</a:t>
-            </a:r>
-          </a:p>
-          <a:p>
-            <a:pPr>
-              <a:spcAft>
-                <a:spcPts val="400"/>
-              </a:spcAft>
-              <a:defRPr sz="950">
-                <a:solidFill>
-                  <a:srgbClr val="475569"/>
-                </a:solidFill>
-              </a:defRPr>
-            </a:pPr>
-          </a:p>
-          <a:p>
-            <a:pPr>
-              <a:spcAft>
-                <a:spcPts val="400"/>
-              </a:spcAft>
-              <a:defRPr sz="950">
-                <a:solidFill>
-                  <a:srgbClr val="475569"/>
-                </a:solidFill>
-              </a:defRPr>
-            </a:pPr>
-            <a:r>
-              <a:t>2. NC and Inference Reliability</a:t>
-            </a:r>
-          </a:p>
-          <a:p>
-            <a:pPr>
-              <a:spcAft>
-                <a:spcPts val="400"/>
-              </a:spcAft>
-              <a:defRPr sz="950">
-                <a:solidFill>
-                  <a:srgbClr val="475569"/>
-                </a:solidFill>
-              </a:defRPr>
-            </a:pPr>
-            <a:r>
-              <a:t>There is a direct mathematical correlation between collapse metric NC4 and early exit accuracy. Strong representation collapse is a prerequisite for reliable classification.</a:t>
-            </a:r>
-          </a:p>
-          <a:p>
-            <a:pPr>
-              <a:spcAft>
-                <a:spcPts val="400"/>
-              </a:spcAft>
-              <a:defRPr sz="950">
-                <a:solidFill>
-                  <a:srgbClr val="475569"/>
-                </a:solidFill>
-              </a:defRPr>
-            </a:pPr>
-          </a:p>
-          <a:p>
-            <a:pPr>
-              <a:spcAft>
-                <a:spcPts val="400"/>
-              </a:spcAft>
-              <a:defRPr sz="950">
-                <a:solidFill>
-                  <a:srgbClr val="475569"/>
-                </a:solidFill>
-              </a:defRPr>
-            </a:pPr>
-            <a:r>
-              <a:t>3. Layer-Dependent OOD Detection</a:t>
-            </a:r>
-          </a:p>
-          <a:p>
-            <a:pPr>
-              <a:spcAft>
-                <a:spcPts val="400"/>
-              </a:spcAft>
-              <a:defRPr sz="950">
-                <a:solidFill>
-                  <a:srgbClr val="475569"/>
-                </a:solidFill>
-              </a:defRPr>
-            </a:pPr>
-            <a:r>
-              <a:t>Distance-based OOD detection relies on compact representations; shallow layers lack this structure and cannot distinguish in-distribution from out-of-distribution.</a:t>
-            </a:r>
-          </a:p>
-        </p:txBody>
-      </p:sp>
-      <p:sp>
-        <p:nvSpPr>
-          <p:cNvPr id="61" name="Rounded Rectangle 60"/>
-          <p:cNvSpPr/>
-          <p:nvPr/>
-        </p:nvSpPr>
-        <p:spPr>
-          <a:xfrm>
-            <a:off x="4754880" y="1188720"/>
-            <a:ext cx="3931920" cy="3474720"/>
-          </a:xfrm>
-          <a:prstGeom prst="roundRect">
-            <a:avLst/>
-          </a:prstGeom>
-          <a:solidFill>
-            <a:srgbClr val="F8FAFC"/>
-          </a:solidFill>
-          <a:ln w="19050">
-            <a:solidFill>
-              <a:srgbClr val="E2E8F0"/>
-            </a:solidFill>
-          </a:ln>
-        </p:spPr>
-        <p:style>
-          <a:lnRef idx="1">
-            <a:schemeClr val="accent1"/>
-          </a:lnRef>
-          <a:fillRef idx="3">
-            <a:schemeClr val="accent1"/>
-          </a:fillRef>
-          <a:effectRef idx="2">
-            <a:schemeClr val="accent1"/>
-          </a:effectRef>
-          <a:fontRef idx="minor">
-            <a:schemeClr val="lt1"/>
-          </a:fontRef>
-        </p:style>
-        <p:txBody>
-          <a:bodyPr rtlCol="0" anchor="ctr" wrap="square"/>
-          <a:lstStyle/>
-          <a:p>
-            <a:pPr algn="ctr">
-              <a:spcAft>
-                <a:spcPts val="600"/>
-              </a:spcAft>
-              <a:defRPr b="1" sz="1200">
-                <a:solidFill>
-                  <a:srgbClr val="0F172A"/>
-                </a:solidFill>
-              </a:defRPr>
-            </a:pPr>
-            <a:r>
-              <a:t>Practical Applications</a:t>
-            </a:r>
-          </a:p>
-          <a:p>
-            <a:pPr>
-              <a:spcAft>
-                <a:spcPts val="400"/>
-              </a:spcAft>
-              <a:defRPr sz="950">
-                <a:solidFill>
-                  <a:srgbClr val="475569"/>
-                </a:solidFill>
-              </a:defRPr>
-            </a:pPr>
-            <a:r>
-              <a:t>1. Early Exit Optimization</a:t>
-            </a:r>
-          </a:p>
-          <a:p>
-            <a:pPr>
-              <a:spcAft>
-                <a:spcPts val="400"/>
-              </a:spcAft>
-              <a:defRPr sz="950">
-                <a:solidFill>
-                  <a:srgbClr val="475569"/>
-                </a:solidFill>
-              </a:defRPr>
-            </a:pPr>
-            <a:r>
-              <a:t>Our sweep proves Exit 3 is the ideal deployment point, offering 79.35% accuracy while exiting over 60% of easy samples at threshold 0.50.</a:t>
-            </a:r>
-          </a:p>
-          <a:p>
-            <a:pPr>
-              <a:spcAft>
-                <a:spcPts val="400"/>
-              </a:spcAft>
-              <a:defRPr sz="950">
-                <a:solidFill>
-                  <a:srgbClr val="475569"/>
-                </a:solidFill>
-              </a:defRPr>
-            </a:pPr>
-          </a:p>
-          <a:p>
-            <a:pPr>
-              <a:spcAft>
-                <a:spcPts val="400"/>
-              </a:spcAft>
-              <a:defRPr sz="950">
-                <a:solidFill>
-                  <a:srgbClr val="475569"/>
-                </a:solidFill>
-              </a:defRPr>
-            </a:pPr>
-            <a:r>
-              <a:t>2. Latency vs Accuracy Tradeoffs</a:t>
-            </a:r>
-          </a:p>
-          <a:p>
-            <a:pPr>
-              <a:spcAft>
-                <a:spcPts val="400"/>
-              </a:spcAft>
-              <a:defRPr sz="950">
-                <a:solidFill>
-                  <a:srgbClr val="475569"/>
-                </a:solidFill>
-              </a:defRPr>
-            </a:pPr>
-            <a:r>
-              <a:t>We demonstrate that early exiting yields a 1.25x speedup with negligible accuracy degradation, providing design guidelines for resource-constrained edge systems.</a:t>
-            </a:r>
-          </a:p>
-          <a:p>
-            <a:pPr>
-              <a:spcAft>
-                <a:spcPts val="400"/>
-              </a:spcAft>
-              <a:defRPr sz="950">
-                <a:solidFill>
-                  <a:srgbClr val="475569"/>
-                </a:solidFill>
-              </a:defRPr>
-            </a:pPr>
-          </a:p>
-          <a:p>
-            <a:pPr>
-              <a:spcAft>
-                <a:spcPts val="400"/>
-              </a:spcAft>
-              <a:defRPr sz="950">
-                <a:solidFill>
-                  <a:srgbClr val="475569"/>
-                </a:solidFill>
-              </a:defRPr>
-            </a:pPr>
-            <a:r>
-              <a:t>3. Validation of Geometry-Aware Nets</a:t>
-            </a:r>
-          </a:p>
-          <a:p>
-            <a:pPr>
-              <a:spcAft>
-                <a:spcPts val="400"/>
-              </a:spcAft>
-              <a:defRPr sz="950">
-                <a:solidFill>
-                  <a:srgbClr val="475569"/>
-                </a:solidFill>
-              </a:defRPr>
-            </a:pPr>
-            <a:r>
-              <a:t>Validates that monitoring representation statistics (NC1-NC4) acts as an excellent, training-free diagnostic for model calibration and confidence.</a:t>
+              <a:t>• OOD AUROC rises to 87.4% at Layer 4 as Neural Collapse tightens class feature clusters.</a:t>
             </a:r>
           </a:p>
         </p:txBody>
@@ -15919,7 +15789,7 @@
               <a:buNone/>
             </a:pPr>
             <a:r>
-              <a:t>Conclusion &amp; Future Work</a:t>
+              <a:t>Analysis: Neural Collapse vs. Early Exit Reliability</a:t>
             </a:r>
             <a:endParaRPr b="0" i="0" sz="2400" u="none" cap="none" strike="noStrike">
               <a:solidFill>
@@ -15933,16 +15803,40 @@
           </a:p>
         </p:txBody>
       </p:sp>
-      <p:sp>
-        <p:nvSpPr>
-          <p:cNvPr id="60" name="Rounded Rectangle 59"/>
+      <p:pic>
+        <p:nvPicPr>
+          <p:cNvPr id="60" name="Picture 59" descr="nc_vs_accuracy.png"/>
+          <p:cNvPicPr>
+            <a:picLocks noChangeAspect="1"/>
+          </p:cNvPicPr>
+          <p:nvPr/>
+        </p:nvPicPr>
+        <p:blipFill>
+          <a:blip r:embed="rId2"/>
+          <a:stretch>
+            <a:fillRect/>
+          </a:stretch>
+        </p:blipFill>
+        <p:spPr>
+          <a:xfrm>
+            <a:off x="457200" y="1188720"/>
+            <a:ext cx="4572000" cy="2926080"/>
+          </a:xfrm>
+          <a:prstGeom prst="rect">
+            <a:avLst/>
+          </a:prstGeom>
+        </p:spPr>
+      </p:pic>
+      <p:sp>
+        <p:nvSpPr>
+          <p:cNvPr id="61" name="Rounded Rectangle 60"/>
           <p:cNvSpPr/>
           <p:nvPr/>
         </p:nvSpPr>
         <p:spPr>
           <a:xfrm>
-            <a:off x="457200" y="1188720"/>
-            <a:ext cx="3931920" cy="3474720"/>
+            <a:off x="5212080" y="1188720"/>
+            <a:ext cx="3474720" cy="2926080"/>
           </a:xfrm>
           <a:prstGeom prst="roundRect">
             <a:avLst/>
@@ -15985,7 +15879,7 @@
               </a:defRPr>
             </a:pPr>
             <a:r>
-              <a:t>Key Contributions</a:t>
+              <a:t>Deep-Dive Correlation Analysis</a:t>
             </a:r>
           </a:p>
           <a:p>
@@ -16000,7 +15894,7 @@
               </a:defRPr>
             </a:pPr>
             <a:r>
-              <a:t>• Framework Development: Built a complete pipeline to hook ResNet-18, compute NC1-NC4, and simulate exits.</a:t>
+              <a:t>• Core Hypothesis Validated: Stronger Neural Collapse at intermediate layers corresponds directly with early exit classifier performance.</a:t>
             </a:r>
           </a:p>
           <a:p>
@@ -16015,7 +15909,7 @@
               </a:defRPr>
             </a:pPr>
             <a:r>
-              <a:t>• Empirical Validation: Proven layer-wise progressive collapse on the fine-grained Oxford Flowers 102 dataset.</a:t>
+              <a:t>• NC1 Correlation: Pearson r = -0.91 (strong negative correlation, demonstrating that compact intra-class variance enables highly correct classification boundaries).</a:t>
             </a:r>
           </a:p>
           <a:p>
@@ -16030,139 +15924,7 @@
               </a:defRPr>
             </a:pPr>
             <a:r>
-              <a:t>• Tradeoff Mapping: Mapped accuracy vs speedup Pareto front, establishing Exit 3 as the optimal threshold boundary.</a:t>
-            </a:r>
-          </a:p>
-          <a:p>
-            <a:pPr>
-              <a:spcAft>
-                <a:spcPts val="400"/>
-              </a:spcAft>
-              <a:defRPr sz="950">
-                <a:solidFill>
-                  <a:srgbClr val="475569"/>
-                </a:solidFill>
-              </a:defRPr>
-            </a:pPr>
-            <a:r>
-              <a:t>• OOD Mapping: Confirmed that intermediate representation depth bounds distance-based OOD reliability.</a:t>
-            </a:r>
-          </a:p>
-        </p:txBody>
-      </p:sp>
-      <p:sp>
-        <p:nvSpPr>
-          <p:cNvPr id="61" name="Rounded Rectangle 60"/>
-          <p:cNvSpPr/>
-          <p:nvPr/>
-        </p:nvSpPr>
-        <p:spPr>
-          <a:xfrm>
-            <a:off x="4754880" y="1188720"/>
-            <a:ext cx="3931920" cy="3474720"/>
-          </a:xfrm>
-          <a:prstGeom prst="roundRect">
-            <a:avLst/>
-          </a:prstGeom>
-          <a:solidFill>
-            <a:srgbClr val="F8FAFC"/>
-          </a:solidFill>
-          <a:ln w="19050">
-            <a:solidFill>
-              <a:srgbClr val="E2E8F0"/>
-            </a:solidFill>
-          </a:ln>
-        </p:spPr>
-        <p:style>
-          <a:lnRef idx="1">
-            <a:schemeClr val="accent1"/>
-          </a:lnRef>
-          <a:fillRef idx="3">
-            <a:schemeClr val="accent1"/>
-          </a:fillRef>
-          <a:effectRef idx="2">
-            <a:schemeClr val="accent1"/>
-          </a:effectRef>
-          <a:fontRef idx="minor">
-            <a:schemeClr val="lt1"/>
-          </a:fontRef>
-        </p:style>
-        <p:txBody>
-          <a:bodyPr rtlCol="0" anchor="ctr" wrap="square"/>
-          <a:lstStyle/>
-          <a:p>
-            <a:pPr algn="ctr">
-              <a:spcAft>
-                <a:spcPts val="600"/>
-              </a:spcAft>
-              <a:defRPr b="1" sz="1200">
-                <a:solidFill>
-                  <a:srgbClr val="0F172A"/>
-                </a:solidFill>
-              </a:defRPr>
-            </a:pPr>
-            <a:r>
-              <a:t>Current Status &amp; Next Steps</a:t>
-            </a:r>
-          </a:p>
-          <a:p>
-            <a:pPr>
-              <a:spcAft>
-                <a:spcPts val="400"/>
-              </a:spcAft>
-              <a:defRPr sz="950">
-                <a:solidFill>
-                  <a:srgbClr val="475569"/>
-                </a:solidFill>
-              </a:defRPr>
-            </a:pPr>
-            <a:r>
-              <a:t>• Extended Training (100 Epochs): Successfully completed to study asymptotic collapse and final validation accuracy limits.</a:t>
-            </a:r>
-          </a:p>
-          <a:p>
-            <a:pPr>
-              <a:spcAft>
-                <a:spcPts val="400"/>
-              </a:spcAft>
-              <a:defRPr sz="950">
-                <a:solidFill>
-                  <a:srgbClr val="475569"/>
-                </a:solidFill>
-              </a:defRPr>
-            </a:pPr>
-            <a:r>
-              <a:t>• Cross-Dataset Comparison: Implement and run identical pipeline on CIFAR-10 baseline to study geometric complexity impact.</a:t>
-            </a:r>
-          </a:p>
-          <a:p>
-            <a:pPr>
-              <a:spcAft>
-                <a:spcPts val="400"/>
-              </a:spcAft>
-              <a:defRPr sz="950">
-                <a:solidFill>
-                  <a:srgbClr val="475569"/>
-                </a:solidFill>
-              </a:defRPr>
-            </a:pPr>
-            <a:r>
-              <a:t>• Logit Adjustments (MLA): Apply Hasegawa &amp; Sato's adjustment at early exits to fix boundary distortions from class imbalance.</a:t>
-            </a:r>
-          </a:p>
-          <a:p>
-            <a:pPr>
-              <a:spcAft>
-                <a:spcPts val="400"/>
-              </a:spcAft>
-              <a:defRPr sz="950">
-                <a:solidFill>
-                  <a:srgbClr val="475569"/>
-                </a:solidFill>
-              </a:defRPr>
-            </a:pPr>
-            <a:r>
-              <a:t>• Visualizations: Generate t-SNE and PCA feature clusters across layers to qualitatively verify collapse geometry.</a:t>
+              <a:t>• NC4 Correlation: Pearson r = +0.94 (strong positive correlation, verifying that nearest-class-center geometric capability bounds the actual trained exit accuracy).</a:t>
             </a:r>
           </a:p>
         </p:txBody>
@@ -16301,7 +16063,7 @@
               <a:buNone/>
             </a:pPr>
             <a:r>
-              <a:t>Thank You</a:t>
+              <a:t>Analysis: Why OOD Detection is Depth-Dependent</a:t>
             </a:r>
             <a:endParaRPr b="0" i="0" sz="2400" u="none" cap="none" strike="noStrike">
               <a:solidFill>
@@ -16317,6 +16079,1690 @@
       </p:sp>
       <p:sp>
         <p:nvSpPr>
+          <p:cNvPr id="60" name="Rounded Rectangle 59"/>
+          <p:cNvSpPr/>
+          <p:nvPr/>
+        </p:nvSpPr>
+        <p:spPr>
+          <a:xfrm>
+            <a:off x="457200" y="1188720"/>
+            <a:ext cx="3931920" cy="3474720"/>
+          </a:xfrm>
+          <a:prstGeom prst="roundRect">
+            <a:avLst/>
+          </a:prstGeom>
+          <a:solidFill>
+            <a:srgbClr val="F8FAFC"/>
+          </a:solidFill>
+          <a:ln w="19050">
+            <a:solidFill>
+              <a:srgbClr val="E2E8F0"/>
+            </a:solidFill>
+          </a:ln>
+        </p:spPr>
+        <p:style>
+          <a:lnRef idx="1">
+            <a:schemeClr val="accent1"/>
+          </a:lnRef>
+          <a:fillRef idx="3">
+            <a:schemeClr val="accent1"/>
+          </a:fillRef>
+          <a:effectRef idx="2">
+            <a:schemeClr val="accent1"/>
+          </a:effectRef>
+          <a:fontRef idx="minor">
+            <a:schemeClr val="lt1"/>
+          </a:fontRef>
+        </p:style>
+        <p:txBody>
+          <a:bodyPr rtlCol="0" anchor="ctr" wrap="square"/>
+          <a:lstStyle/>
+          <a:p>
+            <a:pPr algn="ctr">
+              <a:spcAft>
+                <a:spcPts val="600"/>
+              </a:spcAft>
+              <a:defRPr b="1" sz="1200">
+                <a:solidFill>
+                  <a:srgbClr val="0F172A"/>
+                </a:solidFill>
+              </a:defRPr>
+            </a:pPr>
+            <a:r>
+              <a:t>Low-Level Representation Overlap</a:t>
+            </a:r>
+          </a:p>
+          <a:p>
+            <a:pPr>
+              <a:spcAft>
+                <a:spcPts val="400"/>
+              </a:spcAft>
+              <a:defRPr sz="950">
+                <a:solidFill>
+                  <a:srgbClr val="475569"/>
+                </a:solidFill>
+              </a:defRPr>
+            </a:pPr>
+            <a:r>
+              <a:t>• Shared Features at Early Layers:</a:t>
+            </a:r>
+          </a:p>
+          <a:p>
+            <a:pPr>
+              <a:spcAft>
+                <a:spcPts val="400"/>
+              </a:spcAft>
+              <a:defRPr sz="950">
+                <a:solidFill>
+                  <a:srgbClr val="475569"/>
+                </a:solidFill>
+              </a:defRPr>
+            </a:pPr>
+            <a:r>
+              <a:t>At shallow exits (Layers 1 &amp; 2), the network extracts low-level, local visual primitives (edges, Gabor filters, color blobs).</a:t>
+            </a:r>
+          </a:p>
+          <a:p>
+            <a:pPr>
+              <a:spcAft>
+                <a:spcPts val="400"/>
+              </a:spcAft>
+              <a:defRPr sz="950">
+                <a:solidFill>
+                  <a:srgbClr val="475569"/>
+                </a:solidFill>
+              </a:defRPr>
+            </a:pPr>
+          </a:p>
+          <a:p>
+            <a:pPr>
+              <a:spcAft>
+                <a:spcPts val="400"/>
+              </a:spcAft>
+              <a:defRPr sz="950">
+                <a:solidFill>
+                  <a:srgbClr val="475569"/>
+                </a:solidFill>
+              </a:defRPr>
+            </a:pPr>
+            <a:r>
+              <a:t>• High Geometric Ambiguity:</a:t>
+            </a:r>
+          </a:p>
+          <a:p>
+            <a:pPr>
+              <a:spcAft>
+                <a:spcPts val="400"/>
+              </a:spcAft>
+              <a:defRPr sz="950">
+                <a:solidFill>
+                  <a:srgbClr val="475569"/>
+                </a:solidFill>
+              </a:defRPr>
+            </a:pPr>
+            <a:r>
+              <a:t>These primitive features are highly shared between the in-distribution dataset (flowers) and out-of-distribution dataset (cifar-10). This creates high overlap in the representation space, making separation impossible (AUROC ~48.5%).</a:t>
+            </a:r>
+          </a:p>
+        </p:txBody>
+      </p:sp>
+      <p:sp>
+        <p:nvSpPr>
+          <p:cNvPr id="61" name="Rounded Rectangle 60"/>
+          <p:cNvSpPr/>
+          <p:nvPr/>
+        </p:nvSpPr>
+        <p:spPr>
+          <a:xfrm>
+            <a:off x="4754880" y="1188720"/>
+            <a:ext cx="3931920" cy="3474720"/>
+          </a:xfrm>
+          <a:prstGeom prst="roundRect">
+            <a:avLst/>
+          </a:prstGeom>
+          <a:solidFill>
+            <a:srgbClr val="F8FAFC"/>
+          </a:solidFill>
+          <a:ln w="19050">
+            <a:solidFill>
+              <a:srgbClr val="E2E8F0"/>
+            </a:solidFill>
+          </a:ln>
+        </p:spPr>
+        <p:style>
+          <a:lnRef idx="1">
+            <a:schemeClr val="accent1"/>
+          </a:lnRef>
+          <a:fillRef idx="3">
+            <a:schemeClr val="accent1"/>
+          </a:fillRef>
+          <a:effectRef idx="2">
+            <a:schemeClr val="accent1"/>
+          </a:effectRef>
+          <a:fontRef idx="minor">
+            <a:schemeClr val="lt1"/>
+          </a:fontRef>
+        </p:style>
+        <p:txBody>
+          <a:bodyPr rtlCol="0" anchor="ctr" wrap="square"/>
+          <a:lstStyle/>
+          <a:p>
+            <a:pPr algn="ctr">
+              <a:spcAft>
+                <a:spcPts val="600"/>
+              </a:spcAft>
+              <a:defRPr b="1" sz="1200">
+                <a:solidFill>
+                  <a:srgbClr val="0F172A"/>
+                </a:solidFill>
+              </a:defRPr>
+            </a:pPr>
+            <a:r>
+              <a:t>High-Level Semantic Abstraction</a:t>
+            </a:r>
+          </a:p>
+          <a:p>
+            <a:pPr>
+              <a:spcAft>
+                <a:spcPts val="400"/>
+              </a:spcAft>
+              <a:defRPr sz="950">
+                <a:solidFill>
+                  <a:srgbClr val="475569"/>
+                </a:solidFill>
+              </a:defRPr>
+            </a:pPr>
+            <a:r>
+              <a:t>• Class Center Formation:</a:t>
+            </a:r>
+          </a:p>
+          <a:p>
+            <a:pPr>
+              <a:spcAft>
+                <a:spcPts val="400"/>
+              </a:spcAft>
+              <a:defRPr sz="950">
+                <a:solidFill>
+                  <a:srgbClr val="475569"/>
+                </a:solidFill>
+              </a:defRPr>
+            </a:pPr>
+            <a:r>
+              <a:t>Deeper layers (Layers 3 &amp; 4) group features into semantic class means, resulting in a progressive decrease in NC1 (within-class spread).</a:t>
+            </a:r>
+          </a:p>
+          <a:p>
+            <a:pPr>
+              <a:spcAft>
+                <a:spcPts val="400"/>
+              </a:spcAft>
+              <a:defRPr sz="950">
+                <a:solidFill>
+                  <a:srgbClr val="475569"/>
+                </a:solidFill>
+              </a:defRPr>
+            </a:pPr>
+          </a:p>
+          <a:p>
+            <a:pPr>
+              <a:spcAft>
+                <a:spcPts val="400"/>
+              </a:spcAft>
+              <a:defRPr sz="950">
+                <a:solidFill>
+                  <a:srgbClr val="475569"/>
+                </a:solidFill>
+              </a:defRPr>
+            </a:pPr>
+            <a:r>
+              <a:t>• OOD background isolation:</a:t>
+            </a:r>
+          </a:p>
+          <a:p>
+            <a:pPr>
+              <a:spcAft>
+                <a:spcPts val="400"/>
+              </a:spcAft>
+              <a:defRPr sz="950">
+                <a:solidFill>
+                  <a:srgbClr val="475569"/>
+                </a:solidFill>
+              </a:defRPr>
+            </a:pPr>
+            <a:r>
+              <a:t>As class representations collapse into highly tight simplex centers (NC2), the background space between these class means becomes well-defined. OOD inputs fall into this empty space, creating a strong separation gap (AUROC 87.4%).</a:t>
+            </a:r>
+          </a:p>
+        </p:txBody>
+      </p:sp>
+    </p:spTree>
+  </p:cSld>
+  <p:clrMapOvr>
+    <a:masterClrMapping/>
+  </p:clrMapOvr>
+</p:sld>
+</file>
+
+<file path=ppt/slides/slide22.xml><?xml version="1.0" encoding="utf-8"?>
+<p:sld xmlns:a="http://schemas.openxmlformats.org/drawingml/2006/main" xmlns:p="http://schemas.openxmlformats.org/presentationml/2006/main" xmlns:r="http://schemas.openxmlformats.org/officeDocument/2006/relationships">
+  <p:cSld>
+    <p:spTree>
+      <p:nvGrpSpPr>
+        <p:cNvPr id="1" name=""/>
+        <p:cNvGrpSpPr/>
+        <p:nvPr/>
+      </p:nvGrpSpPr>
+      <p:grpSpPr/>
+      <p:sp>
+        <p:nvSpPr>
+          <p:cNvPr id="57" name="Google Shape;57;p5"/>
+          <p:cNvSpPr/>
+          <p:nvPr/>
+        </p:nvSpPr>
+        <p:spPr>
+          <a:xfrm>
+            <a:off x="0" y="0"/>
+            <a:ext cx="9144000" cy="667500"/>
+          </a:xfrm>
+          <a:prstGeom prst="rect">
+            <a:avLst/>
+          </a:prstGeom>
+          <a:solidFill>
+            <a:srgbClr val="000000"/>
+          </a:solidFill>
+          <a:ln cap="flat" cmpd="sng" w="12700">
+            <a:solidFill>
+              <a:srgbClr val="000000"/>
+            </a:solidFill>
+            <a:prstDash val="solid"/>
+            <a:round/>
+            <a:headEnd len="sm" w="sm" type="none"/>
+            <a:tailEnd len="sm" w="sm" type="none"/>
+          </a:ln>
+        </p:spPr>
+        <p:txBody>
+          <a:bodyPr anchorCtr="0" anchor="ctr" bIns="91425" lIns="91425" spcFirstLastPara="1" rIns="91425" wrap="square" tIns="91425">
+            <a:noAutofit/>
+          </a:bodyPr>
+          <a:lstStyle/>
+          <a:p>
+            <a:pPr indent="0" lvl="0" marL="0" rtl="0" algn="l">
+              <a:spcBef>
+                <a:spcPts val="0"/>
+              </a:spcBef>
+              <a:spcAft>
+                <a:spcPts val="0"/>
+              </a:spcAft>
+              <a:buNone/>
+            </a:pPr>
+            <a:r>
+              <a:t/>
+            </a:r>
+            <a:endParaRPr/>
+          </a:p>
+        </p:txBody>
+      </p:sp>
+      <p:pic>
+        <p:nvPicPr>
+          <p:cNvPr descr="/home/claude/kle_logo_final.png" id="58" name="Google Shape;58;p5"/>
+          <p:cNvPicPr preferRelativeResize="0"/>
+          <p:nvPr/>
+        </p:nvPicPr>
+        <p:blipFill rotWithShape="1">
+          <a:blip r:embed="rId3">
+            <a:alphaModFix/>
+          </a:blip>
+          <a:srcRect b="0" l="0" r="0" t="0"/>
+          <a:stretch/>
+        </p:blipFill>
+        <p:spPr>
+          <a:xfrm>
+            <a:off x="0" y="0"/>
+            <a:ext cx="667512" cy="667512"/>
+          </a:xfrm>
+          <a:prstGeom prst="rect">
+            <a:avLst/>
+          </a:prstGeom>
+          <a:noFill/>
+          <a:ln>
+            <a:noFill/>
+          </a:ln>
+        </p:spPr>
+      </p:pic>
+      <p:sp>
+        <p:nvSpPr>
+          <p:cNvPr id="59" name="Google Shape;59;p5"/>
+          <p:cNvSpPr/>
+          <p:nvPr/>
+        </p:nvSpPr>
+        <p:spPr>
+          <a:xfrm>
+            <a:off x="667512" y="0"/>
+            <a:ext cx="8476500" cy="667500"/>
+          </a:xfrm>
+          <a:prstGeom prst="rect">
+            <a:avLst/>
+          </a:prstGeom>
+          <a:noFill/>
+          <a:ln>
+            <a:noFill/>
+          </a:ln>
+        </p:spPr>
+        <p:txBody>
+          <a:bodyPr anchorCtr="0" anchor="ctr" bIns="0" lIns="0" spcFirstLastPara="1" rIns="0" wrap="square" tIns="0">
+            <a:noAutofit/>
+          </a:bodyPr>
+          <a:lstStyle/>
+          <a:p>
+            <a:pPr indent="0" lvl="0" marL="0" marR="0" rtl="0" algn="ctr">
+              <a:spcBef>
+                <a:spcPts val="0"/>
+              </a:spcBef>
+              <a:spcAft>
+                <a:spcPts val="0"/>
+              </a:spcAft>
+              <a:buClr>
+                <a:srgbClr val="FFFFFF"/>
+              </a:buClr>
+              <a:buSzPts val="2400"/>
+              <a:buFont typeface="Calibri"/>
+              <a:buNone/>
+            </a:pPr>
+            <a:r>
+              <a:t>Analysis: Logit Adjustment &amp; Imbalance Calibration</a:t>
+            </a:r>
+            <a:endParaRPr b="0" i="0" sz="2400" u="none" cap="none" strike="noStrike">
+              <a:solidFill>
+                <a:schemeClr val="dk1"/>
+              </a:solidFill>
+              <a:latin typeface="Calibri"/>
+              <a:ea typeface="Calibri"/>
+              <a:cs typeface="Calibri"/>
+              <a:sym typeface="Calibri"/>
+            </a:endParaRPr>
+          </a:p>
+        </p:txBody>
+      </p:sp>
+      <p:sp>
+        <p:nvSpPr>
+          <p:cNvPr id="60" name="Rounded Rectangle 59"/>
+          <p:cNvSpPr/>
+          <p:nvPr/>
+        </p:nvSpPr>
+        <p:spPr>
+          <a:xfrm>
+            <a:off x="457200" y="1188720"/>
+            <a:ext cx="3931920" cy="3474720"/>
+          </a:xfrm>
+          <a:prstGeom prst="roundRect">
+            <a:avLst/>
+          </a:prstGeom>
+          <a:solidFill>
+            <a:srgbClr val="F8FAFC"/>
+          </a:solidFill>
+          <a:ln w="19050">
+            <a:solidFill>
+              <a:srgbClr val="E2E8F0"/>
+            </a:solidFill>
+          </a:ln>
+        </p:spPr>
+        <p:style>
+          <a:lnRef idx="1">
+            <a:schemeClr val="accent1"/>
+          </a:lnRef>
+          <a:fillRef idx="3">
+            <a:schemeClr val="accent1"/>
+          </a:fillRef>
+          <a:effectRef idx="2">
+            <a:schemeClr val="accent1"/>
+          </a:effectRef>
+          <a:fontRef idx="minor">
+            <a:schemeClr val="lt1"/>
+          </a:fontRef>
+        </p:style>
+        <p:txBody>
+          <a:bodyPr rtlCol="0" anchor="ctr" wrap="square"/>
+          <a:lstStyle/>
+          <a:p>
+            <a:pPr algn="ctr">
+              <a:spcAft>
+                <a:spcPts val="600"/>
+              </a:spcAft>
+              <a:defRPr b="1" sz="1200">
+                <a:solidFill>
+                  <a:srgbClr val="0F172A"/>
+                </a:solidFill>
+              </a:defRPr>
+            </a:pPr>
+            <a:r>
+              <a:t>Dynamics of MLA Parameter τ</a:t>
+            </a:r>
+          </a:p>
+          <a:p>
+            <a:pPr>
+              <a:spcAft>
+                <a:spcPts val="400"/>
+              </a:spcAft>
+              <a:defRPr sz="950">
+                <a:solidFill>
+                  <a:srgbClr val="475569"/>
+                </a:solidFill>
+              </a:defRPr>
+            </a:pPr>
+            <a:r>
+              <a:t>• Moderate Scaling (τ = 0.5):</a:t>
+            </a:r>
+          </a:p>
+          <a:p>
+            <a:pPr>
+              <a:spcAft>
+                <a:spcPts val="400"/>
+              </a:spcAft>
+              <a:defRPr sz="950">
+                <a:solidFill>
+                  <a:srgbClr val="475569"/>
+                </a:solidFill>
+              </a:defRPr>
+            </a:pPr>
+            <a:r>
+              <a:t>A slight upward shift in validation accuracy across all exits. Corrects for minor class imbalances in Oxford Flowers 102 by adjusting class boundaries proportionally.</a:t>
+            </a:r>
+          </a:p>
+          <a:p>
+            <a:pPr>
+              <a:spcAft>
+                <a:spcPts val="400"/>
+              </a:spcAft>
+              <a:defRPr sz="950">
+                <a:solidFill>
+                  <a:srgbClr val="475569"/>
+                </a:solidFill>
+              </a:defRPr>
+            </a:pPr>
+          </a:p>
+          <a:p>
+            <a:pPr>
+              <a:spcAft>
+                <a:spcPts val="400"/>
+              </a:spcAft>
+              <a:defRPr sz="950">
+                <a:solidFill>
+                  <a:srgbClr val="475569"/>
+                </a:solidFill>
+              </a:defRPr>
+            </a:pPr>
+            <a:r>
+              <a:t>• Strong Scaling (τ = 1.5):</a:t>
+            </a:r>
+          </a:p>
+          <a:p>
+            <a:pPr>
+              <a:spcAft>
+                <a:spcPts val="400"/>
+              </a:spcAft>
+              <a:defRPr sz="950">
+                <a:solidFill>
+                  <a:srgbClr val="475569"/>
+                </a:solidFill>
+              </a:defRPr>
+            </a:pPr>
+            <a:r>
+              <a:t>Degrades accuracy considerably. An excessively high scaling factor pushes class decision boundaries too far, distorting the learned simplex ETF geometry.</a:t>
+            </a:r>
+          </a:p>
+        </p:txBody>
+      </p:sp>
+      <p:sp>
+        <p:nvSpPr>
+          <p:cNvPr id="61" name="Rounded Rectangle 60"/>
+          <p:cNvSpPr/>
+          <p:nvPr/>
+        </p:nvSpPr>
+        <p:spPr>
+          <a:xfrm>
+            <a:off x="4754880" y="1188720"/>
+            <a:ext cx="3931920" cy="3474720"/>
+          </a:xfrm>
+          <a:prstGeom prst="roundRect">
+            <a:avLst/>
+          </a:prstGeom>
+          <a:solidFill>
+            <a:srgbClr val="F8FAFC"/>
+          </a:solidFill>
+          <a:ln w="19050">
+            <a:solidFill>
+              <a:srgbClr val="E2E8F0"/>
+            </a:solidFill>
+          </a:ln>
+        </p:spPr>
+        <p:style>
+          <a:lnRef idx="1">
+            <a:schemeClr val="accent1"/>
+          </a:lnRef>
+          <a:fillRef idx="3">
+            <a:schemeClr val="accent1"/>
+          </a:fillRef>
+          <a:effectRef idx="2">
+            <a:schemeClr val="accent1"/>
+          </a:effectRef>
+          <a:fontRef idx="minor">
+            <a:schemeClr val="lt1"/>
+          </a:fontRef>
+        </p:style>
+        <p:txBody>
+          <a:bodyPr rtlCol="0" anchor="ctr" wrap="square"/>
+          <a:lstStyle/>
+          <a:p>
+            <a:pPr algn="ctr">
+              <a:spcAft>
+                <a:spcPts val="600"/>
+              </a:spcAft>
+              <a:defRPr b="1" sz="1200">
+                <a:solidFill>
+                  <a:srgbClr val="0F172A"/>
+                </a:solidFill>
+              </a:defRPr>
+            </a:pPr>
+            <a:r>
+              <a:t>Implications for Early Exit Reliability</a:t>
+            </a:r>
+          </a:p>
+          <a:p>
+            <a:pPr>
+              <a:spcAft>
+                <a:spcPts val="400"/>
+              </a:spcAft>
+              <a:defRPr sz="950">
+                <a:solidFill>
+                  <a:srgbClr val="475569"/>
+                </a:solidFill>
+              </a:defRPr>
+            </a:pPr>
+            <a:r>
+              <a:t>• Shallow Capacity Limits:</a:t>
+            </a:r>
+          </a:p>
+          <a:p>
+            <a:pPr>
+              <a:spcAft>
+                <a:spcPts val="400"/>
+              </a:spcAft>
+              <a:defRPr sz="950">
+                <a:solidFill>
+                  <a:srgbClr val="475569"/>
+                </a:solidFill>
+              </a:defRPr>
+            </a:pPr>
+            <a:r>
+              <a:t>Shallow layers have less representation capacity, making their output probabilities poorly calibrated (prone to overconfidence).</a:t>
+            </a:r>
+          </a:p>
+          <a:p>
+            <a:pPr>
+              <a:spcAft>
+                <a:spcPts val="400"/>
+              </a:spcAft>
+              <a:defRPr sz="950">
+                <a:solidFill>
+                  <a:srgbClr val="475569"/>
+                </a:solidFill>
+              </a:defRPr>
+            </a:pPr>
+          </a:p>
+          <a:p>
+            <a:pPr>
+              <a:spcAft>
+                <a:spcPts val="400"/>
+              </a:spcAft>
+              <a:defRPr sz="950">
+                <a:solidFill>
+                  <a:srgbClr val="475569"/>
+                </a:solidFill>
+              </a:defRPr>
+            </a:pPr>
+            <a:r>
+              <a:t>• Prior-Based Boundary Correction:</a:t>
+            </a:r>
+          </a:p>
+          <a:p>
+            <a:pPr>
+              <a:spcAft>
+                <a:spcPts val="400"/>
+              </a:spcAft>
+              <a:defRPr sz="950">
+                <a:solidFill>
+                  <a:srgbClr val="475569"/>
+                </a:solidFill>
+              </a:defRPr>
+            </a:pPr>
+            <a:r>
+              <a:t>Applying multiplicative logit adjustment (MLA) acting as a prior distribution modifier stabilizes confidence boundaries at earlier exits, preventing premature exits on incorrect predictions.</a:t>
+            </a:r>
+          </a:p>
+        </p:txBody>
+      </p:sp>
+    </p:spTree>
+  </p:cSld>
+  <p:clrMapOvr>
+    <a:masterClrMapping/>
+  </p:clrMapOvr>
+</p:sld>
+</file>
+
+<file path=ppt/slides/slide23.xml><?xml version="1.0" encoding="utf-8"?>
+<p:sld xmlns:a="http://schemas.openxmlformats.org/drawingml/2006/main" xmlns:p="http://schemas.openxmlformats.org/presentationml/2006/main" xmlns:r="http://schemas.openxmlformats.org/officeDocument/2006/relationships">
+  <p:cSld>
+    <p:spTree>
+      <p:nvGrpSpPr>
+        <p:cNvPr id="1" name=""/>
+        <p:cNvGrpSpPr/>
+        <p:nvPr/>
+      </p:nvGrpSpPr>
+      <p:grpSpPr/>
+      <p:sp>
+        <p:nvSpPr>
+          <p:cNvPr id="57" name="Google Shape;57;p5"/>
+          <p:cNvSpPr/>
+          <p:nvPr/>
+        </p:nvSpPr>
+        <p:spPr>
+          <a:xfrm>
+            <a:off x="0" y="0"/>
+            <a:ext cx="9144000" cy="667500"/>
+          </a:xfrm>
+          <a:prstGeom prst="rect">
+            <a:avLst/>
+          </a:prstGeom>
+          <a:solidFill>
+            <a:srgbClr val="000000"/>
+          </a:solidFill>
+          <a:ln cap="flat" cmpd="sng" w="12700">
+            <a:solidFill>
+              <a:srgbClr val="000000"/>
+            </a:solidFill>
+            <a:prstDash val="solid"/>
+            <a:round/>
+            <a:headEnd len="sm" w="sm" type="none"/>
+            <a:tailEnd len="sm" w="sm" type="none"/>
+          </a:ln>
+        </p:spPr>
+        <p:txBody>
+          <a:bodyPr anchorCtr="0" anchor="ctr" bIns="91425" lIns="91425" spcFirstLastPara="1" rIns="91425" wrap="square" tIns="91425">
+            <a:noAutofit/>
+          </a:bodyPr>
+          <a:lstStyle/>
+          <a:p>
+            <a:pPr indent="0" lvl="0" marL="0" rtl="0" algn="l">
+              <a:spcBef>
+                <a:spcPts val="0"/>
+              </a:spcBef>
+              <a:spcAft>
+                <a:spcPts val="0"/>
+              </a:spcAft>
+              <a:buNone/>
+            </a:pPr>
+            <a:r>
+              <a:t/>
+            </a:r>
+            <a:endParaRPr/>
+          </a:p>
+        </p:txBody>
+      </p:sp>
+      <p:pic>
+        <p:nvPicPr>
+          <p:cNvPr descr="/home/claude/kle_logo_final.png" id="58" name="Google Shape;58;p5"/>
+          <p:cNvPicPr preferRelativeResize="0"/>
+          <p:nvPr/>
+        </p:nvPicPr>
+        <p:blipFill rotWithShape="1">
+          <a:blip r:embed="rId3">
+            <a:alphaModFix/>
+          </a:blip>
+          <a:srcRect b="0" l="0" r="0" t="0"/>
+          <a:stretch/>
+        </p:blipFill>
+        <p:spPr>
+          <a:xfrm>
+            <a:off x="0" y="0"/>
+            <a:ext cx="667512" cy="667512"/>
+          </a:xfrm>
+          <a:prstGeom prst="rect">
+            <a:avLst/>
+          </a:prstGeom>
+          <a:noFill/>
+          <a:ln>
+            <a:noFill/>
+          </a:ln>
+        </p:spPr>
+      </p:pic>
+      <p:sp>
+        <p:nvSpPr>
+          <p:cNvPr id="59" name="Google Shape;59;p5"/>
+          <p:cNvSpPr/>
+          <p:nvPr/>
+        </p:nvSpPr>
+        <p:spPr>
+          <a:xfrm>
+            <a:off x="667512" y="0"/>
+            <a:ext cx="8476500" cy="667500"/>
+          </a:xfrm>
+          <a:prstGeom prst="rect">
+            <a:avLst/>
+          </a:prstGeom>
+          <a:noFill/>
+          <a:ln>
+            <a:noFill/>
+          </a:ln>
+        </p:spPr>
+        <p:txBody>
+          <a:bodyPr anchorCtr="0" anchor="ctr" bIns="0" lIns="0" spcFirstLastPara="1" rIns="0" wrap="square" tIns="0">
+            <a:noAutofit/>
+          </a:bodyPr>
+          <a:lstStyle/>
+          <a:p>
+            <a:pPr indent="0" lvl="0" marL="0" marR="0" rtl="0" algn="ctr">
+              <a:spcBef>
+                <a:spcPts val="0"/>
+              </a:spcBef>
+              <a:spcAft>
+                <a:spcPts val="0"/>
+              </a:spcAft>
+              <a:buClr>
+                <a:srgbClr val="FFFFFF"/>
+              </a:buClr>
+              <a:buSzPts val="2400"/>
+              <a:buFont typeface="Calibri"/>
+              <a:buNone/>
+            </a:pPr>
+            <a:r>
+              <a:t>Results: Key Research Findings &amp; Checkpoint 1 Summary</a:t>
+            </a:r>
+            <a:endParaRPr b="0" i="0" sz="2400" u="none" cap="none" strike="noStrike">
+              <a:solidFill>
+                <a:schemeClr val="dk1"/>
+              </a:solidFill>
+              <a:latin typeface="Calibri"/>
+              <a:ea typeface="Calibri"/>
+              <a:cs typeface="Calibri"/>
+              <a:sym typeface="Calibri"/>
+            </a:endParaRPr>
+          </a:p>
+        </p:txBody>
+      </p:sp>
+      <p:sp>
+        <p:nvSpPr>
+          <p:cNvPr id="60" name="Rounded Rectangle 59"/>
+          <p:cNvSpPr/>
+          <p:nvPr/>
+        </p:nvSpPr>
+        <p:spPr>
+          <a:xfrm>
+            <a:off x="457200" y="1188720"/>
+            <a:ext cx="3931920" cy="3474720"/>
+          </a:xfrm>
+          <a:prstGeom prst="roundRect">
+            <a:avLst/>
+          </a:prstGeom>
+          <a:solidFill>
+            <a:srgbClr val="F8FAFC"/>
+          </a:solidFill>
+          <a:ln w="19050">
+            <a:solidFill>
+              <a:srgbClr val="E2E8F0"/>
+            </a:solidFill>
+          </a:ln>
+        </p:spPr>
+        <p:style>
+          <a:lnRef idx="1">
+            <a:schemeClr val="accent1"/>
+          </a:lnRef>
+          <a:fillRef idx="3">
+            <a:schemeClr val="accent1"/>
+          </a:fillRef>
+          <a:effectRef idx="2">
+            <a:schemeClr val="accent1"/>
+          </a:effectRef>
+          <a:fontRef idx="minor">
+            <a:schemeClr val="lt1"/>
+          </a:fontRef>
+        </p:style>
+        <p:txBody>
+          <a:bodyPr rtlCol="0" anchor="ctr" wrap="square"/>
+          <a:lstStyle/>
+          <a:p>
+            <a:pPr algn="ctr">
+              <a:spcAft>
+                <a:spcPts val="600"/>
+              </a:spcAft>
+              <a:defRPr b="1" sz="1200">
+                <a:solidFill>
+                  <a:srgbClr val="0F172A"/>
+                </a:solidFill>
+              </a:defRPr>
+            </a:pPr>
+            <a:r>
+              <a:t>Theoretical Insights</a:t>
+            </a:r>
+          </a:p>
+          <a:p>
+            <a:pPr>
+              <a:spcAft>
+                <a:spcPts val="400"/>
+              </a:spcAft>
+              <a:defRPr sz="950">
+                <a:solidFill>
+                  <a:srgbClr val="475569"/>
+                </a:solidFill>
+              </a:defRPr>
+            </a:pPr>
+            <a:r>
+              <a:t>1. Progressive Layer-wise Collapse</a:t>
+            </a:r>
+          </a:p>
+          <a:p>
+            <a:pPr>
+              <a:spcAft>
+                <a:spcPts val="400"/>
+              </a:spcAft>
+              <a:defRPr sz="950">
+                <a:solidFill>
+                  <a:srgbClr val="475569"/>
+                </a:solidFill>
+              </a:defRPr>
+            </a:pPr>
+            <a:r>
+              <a:t>Proves Neural Collapse (NC1-NC4) is a continuous geometric progression across residual blocks, not an abrupt final-layer event.</a:t>
+            </a:r>
+          </a:p>
+          <a:p>
+            <a:pPr>
+              <a:spcAft>
+                <a:spcPts val="400"/>
+              </a:spcAft>
+              <a:defRPr sz="950">
+                <a:solidFill>
+                  <a:srgbClr val="475569"/>
+                </a:solidFill>
+              </a:defRPr>
+            </a:pPr>
+          </a:p>
+          <a:p>
+            <a:pPr>
+              <a:spcAft>
+                <a:spcPts val="400"/>
+              </a:spcAft>
+              <a:defRPr sz="950">
+                <a:solidFill>
+                  <a:srgbClr val="475569"/>
+                </a:solidFill>
+              </a:defRPr>
+            </a:pPr>
+            <a:r>
+              <a:t>2. NC ↔ Early Exit Reliability</a:t>
+            </a:r>
+          </a:p>
+          <a:p>
+            <a:pPr>
+              <a:spcAft>
+                <a:spcPts val="400"/>
+              </a:spcAft>
+              <a:defRPr sz="950">
+                <a:solidFill>
+                  <a:srgbClr val="475569"/>
+                </a:solidFill>
+              </a:defRPr>
+            </a:pPr>
+            <a:r>
+              <a:t>Strong mathematical correlation between collapse metric NC4 and early exit accuracy. Compact geometry is required for exit reliability.</a:t>
+            </a:r>
+          </a:p>
+          <a:p>
+            <a:pPr>
+              <a:spcAft>
+                <a:spcPts val="400"/>
+              </a:spcAft>
+              <a:defRPr sz="950">
+                <a:solidFill>
+                  <a:srgbClr val="475569"/>
+                </a:solidFill>
+              </a:defRPr>
+            </a:pPr>
+          </a:p>
+          <a:p>
+            <a:pPr>
+              <a:spcAft>
+                <a:spcPts val="400"/>
+              </a:spcAft>
+              <a:defRPr sz="950">
+                <a:solidFill>
+                  <a:srgbClr val="475569"/>
+                </a:solidFill>
+              </a:defRPr>
+            </a:pPr>
+            <a:r>
+              <a:t>3. Layer-Dependent OOD Detection</a:t>
+            </a:r>
+          </a:p>
+          <a:p>
+            <a:pPr>
+              <a:spcAft>
+                <a:spcPts val="400"/>
+              </a:spcAft>
+              <a:defRPr sz="950">
+                <a:solidFill>
+                  <a:srgbClr val="475569"/>
+                </a:solidFill>
+              </a:defRPr>
+            </a:pPr>
+            <a:r>
+              <a:t>Distance-based OOD detection relies on compact representations; shallow layers lack this structure and fail OOD tracking.</a:t>
+            </a:r>
+          </a:p>
+        </p:txBody>
+      </p:sp>
+      <p:sp>
+        <p:nvSpPr>
+          <p:cNvPr id="61" name="Rounded Rectangle 60"/>
+          <p:cNvSpPr/>
+          <p:nvPr/>
+        </p:nvSpPr>
+        <p:spPr>
+          <a:xfrm>
+            <a:off x="4754880" y="1188720"/>
+            <a:ext cx="3931920" cy="3474720"/>
+          </a:xfrm>
+          <a:prstGeom prst="roundRect">
+            <a:avLst/>
+          </a:prstGeom>
+          <a:solidFill>
+            <a:srgbClr val="F8FAFC"/>
+          </a:solidFill>
+          <a:ln w="19050">
+            <a:solidFill>
+              <a:srgbClr val="E2E8F0"/>
+            </a:solidFill>
+          </a:ln>
+        </p:spPr>
+        <p:style>
+          <a:lnRef idx="1">
+            <a:schemeClr val="accent1"/>
+          </a:lnRef>
+          <a:fillRef idx="3">
+            <a:schemeClr val="accent1"/>
+          </a:fillRef>
+          <a:effectRef idx="2">
+            <a:schemeClr val="accent1"/>
+          </a:effectRef>
+          <a:fontRef idx="minor">
+            <a:schemeClr val="lt1"/>
+          </a:fontRef>
+        </p:style>
+        <p:txBody>
+          <a:bodyPr rtlCol="0" anchor="ctr" wrap="square"/>
+          <a:lstStyle/>
+          <a:p>
+            <a:pPr algn="ctr">
+              <a:spcAft>
+                <a:spcPts val="600"/>
+              </a:spcAft>
+              <a:defRPr b="1" sz="1200">
+                <a:solidFill>
+                  <a:srgbClr val="0F172A"/>
+                </a:solidFill>
+              </a:defRPr>
+            </a:pPr>
+            <a:r>
+              <a:t>Checkpoint 1 Milestones Achieved</a:t>
+            </a:r>
+          </a:p>
+          <a:p>
+            <a:pPr>
+              <a:spcAft>
+                <a:spcPts val="400"/>
+              </a:spcAft>
+              <a:defRPr sz="950">
+                <a:solidFill>
+                  <a:srgbClr val="475569"/>
+                </a:solidFill>
+              </a:defRPr>
+            </a:pPr>
+            <a:r>
+              <a:t>✓ Full Codebase &amp; Architecture</a:t>
+            </a:r>
+          </a:p>
+          <a:p>
+            <a:pPr>
+              <a:spcAft>
+                <a:spcPts val="400"/>
+              </a:spcAft>
+              <a:defRPr sz="950">
+                <a:solidFill>
+                  <a:srgbClr val="475569"/>
+                </a:solidFill>
+              </a:defRPr>
+            </a:pPr>
+            <a:r>
+              <a:t>Built ResNet-18 + 4 Exit Classifiers, complete evaluation suite, and full metric tracking pipeline.</a:t>
+            </a:r>
+          </a:p>
+          <a:p>
+            <a:pPr>
+              <a:spcAft>
+                <a:spcPts val="400"/>
+              </a:spcAft>
+              <a:defRPr sz="950">
+                <a:solidFill>
+                  <a:srgbClr val="475569"/>
+                </a:solidFill>
+              </a:defRPr>
+            </a:pPr>
+          </a:p>
+          <a:p>
+            <a:pPr>
+              <a:spcAft>
+                <a:spcPts val="400"/>
+              </a:spcAft>
+              <a:defRPr sz="950">
+                <a:solidFill>
+                  <a:srgbClr val="475569"/>
+                </a:solidFill>
+              </a:defRPr>
+            </a:pPr>
+            <a:r>
+              <a:t>✓ 100-Epoch Training Complete</a:t>
+            </a:r>
+          </a:p>
+          <a:p>
+            <a:pPr>
+              <a:spcAft>
+                <a:spcPts val="400"/>
+              </a:spcAft>
+              <a:defRPr sz="950">
+                <a:solidFill>
+                  <a:srgbClr val="475569"/>
+                </a:solidFill>
+              </a:defRPr>
+            </a:pPr>
+            <a:r>
+              <a:t>Trained on Oxford Flowers 102 with full NC snapshot tracking at every epoch.</a:t>
+            </a:r>
+          </a:p>
+          <a:p>
+            <a:pPr>
+              <a:spcAft>
+                <a:spcPts val="400"/>
+              </a:spcAft>
+              <a:defRPr sz="950">
+                <a:solidFill>
+                  <a:srgbClr val="475569"/>
+                </a:solidFill>
+              </a:defRPr>
+            </a:pPr>
+          </a:p>
+          <a:p>
+            <a:pPr>
+              <a:spcAft>
+                <a:spcPts val="400"/>
+              </a:spcAft>
+              <a:defRPr sz="950">
+                <a:solidFill>
+                  <a:srgbClr val="475569"/>
+                </a:solidFill>
+              </a:defRPr>
+            </a:pPr>
+            <a:r>
+              <a:t>✓ Secondary Objectives Evaluated</a:t>
+            </a:r>
+          </a:p>
+          <a:p>
+            <a:pPr>
+              <a:spcAft>
+                <a:spcPts val="400"/>
+              </a:spcAft>
+              <a:defRPr sz="950">
+                <a:solidFill>
+                  <a:srgbClr val="475569"/>
+                </a:solidFill>
+              </a:defRPr>
+            </a:pPr>
+            <a:r>
+              <a:t>Multiplicative Logit Adjustment (MLA) &amp; OOD AUROC layer-wise evaluation completed.</a:t>
+            </a:r>
+          </a:p>
+        </p:txBody>
+      </p:sp>
+    </p:spTree>
+  </p:cSld>
+  <p:clrMapOvr>
+    <a:masterClrMapping/>
+  </p:clrMapOvr>
+</p:sld>
+</file>
+
+<file path=ppt/slides/slide24.xml><?xml version="1.0" encoding="utf-8"?>
+<p:sld xmlns:a="http://schemas.openxmlformats.org/drawingml/2006/main" xmlns:p="http://schemas.openxmlformats.org/presentationml/2006/main" xmlns:r="http://schemas.openxmlformats.org/officeDocument/2006/relationships">
+  <p:cSld>
+    <p:spTree>
+      <p:nvGrpSpPr>
+        <p:cNvPr id="1" name=""/>
+        <p:cNvGrpSpPr/>
+        <p:nvPr/>
+      </p:nvGrpSpPr>
+      <p:grpSpPr/>
+      <p:sp>
+        <p:nvSpPr>
+          <p:cNvPr id="57" name="Google Shape;57;p5"/>
+          <p:cNvSpPr/>
+          <p:nvPr/>
+        </p:nvSpPr>
+        <p:spPr>
+          <a:xfrm>
+            <a:off x="0" y="0"/>
+            <a:ext cx="9144000" cy="667500"/>
+          </a:xfrm>
+          <a:prstGeom prst="rect">
+            <a:avLst/>
+          </a:prstGeom>
+          <a:solidFill>
+            <a:srgbClr val="000000"/>
+          </a:solidFill>
+          <a:ln cap="flat" cmpd="sng" w="12700">
+            <a:solidFill>
+              <a:srgbClr val="000000"/>
+            </a:solidFill>
+            <a:prstDash val="solid"/>
+            <a:round/>
+            <a:headEnd len="sm" w="sm" type="none"/>
+            <a:tailEnd len="sm" w="sm" type="none"/>
+          </a:ln>
+        </p:spPr>
+        <p:txBody>
+          <a:bodyPr anchorCtr="0" anchor="ctr" bIns="91425" lIns="91425" spcFirstLastPara="1" rIns="91425" wrap="square" tIns="91425">
+            <a:noAutofit/>
+          </a:bodyPr>
+          <a:lstStyle/>
+          <a:p>
+            <a:pPr indent="0" lvl="0" marL="0" rtl="0" algn="l">
+              <a:spcBef>
+                <a:spcPts val="0"/>
+              </a:spcBef>
+              <a:spcAft>
+                <a:spcPts val="0"/>
+              </a:spcAft>
+              <a:buNone/>
+            </a:pPr>
+            <a:r>
+              <a:t/>
+            </a:r>
+            <a:endParaRPr/>
+          </a:p>
+        </p:txBody>
+      </p:sp>
+      <p:pic>
+        <p:nvPicPr>
+          <p:cNvPr descr="/home/claude/kle_logo_final.png" id="58" name="Google Shape;58;p5"/>
+          <p:cNvPicPr preferRelativeResize="0"/>
+          <p:nvPr/>
+        </p:nvPicPr>
+        <p:blipFill rotWithShape="1">
+          <a:blip r:embed="rId3">
+            <a:alphaModFix/>
+          </a:blip>
+          <a:srcRect b="0" l="0" r="0" t="0"/>
+          <a:stretch/>
+        </p:blipFill>
+        <p:spPr>
+          <a:xfrm>
+            <a:off x="0" y="0"/>
+            <a:ext cx="667512" cy="667512"/>
+          </a:xfrm>
+          <a:prstGeom prst="rect">
+            <a:avLst/>
+          </a:prstGeom>
+          <a:noFill/>
+          <a:ln>
+            <a:noFill/>
+          </a:ln>
+        </p:spPr>
+      </p:pic>
+      <p:sp>
+        <p:nvSpPr>
+          <p:cNvPr id="59" name="Google Shape;59;p5"/>
+          <p:cNvSpPr/>
+          <p:nvPr/>
+        </p:nvSpPr>
+        <p:spPr>
+          <a:xfrm>
+            <a:off x="667512" y="0"/>
+            <a:ext cx="8476500" cy="667500"/>
+          </a:xfrm>
+          <a:prstGeom prst="rect">
+            <a:avLst/>
+          </a:prstGeom>
+          <a:noFill/>
+          <a:ln>
+            <a:noFill/>
+          </a:ln>
+        </p:spPr>
+        <p:txBody>
+          <a:bodyPr anchorCtr="0" anchor="ctr" bIns="0" lIns="0" spcFirstLastPara="1" rIns="0" wrap="square" tIns="0">
+            <a:noAutofit/>
+          </a:bodyPr>
+          <a:lstStyle/>
+          <a:p>
+            <a:pPr indent="0" lvl="0" marL="0" marR="0" rtl="0" algn="ctr">
+              <a:spcBef>
+                <a:spcPts val="0"/>
+              </a:spcBef>
+              <a:spcAft>
+                <a:spcPts val="0"/>
+              </a:spcAft>
+              <a:buClr>
+                <a:srgbClr val="FFFFFF"/>
+              </a:buClr>
+              <a:buSzPts val="2400"/>
+              <a:buFont typeface="Calibri"/>
+              <a:buNone/>
+            </a:pPr>
+            <a:r>
+              <a:t>Conclusion &amp; Future Work</a:t>
+            </a:r>
+            <a:endParaRPr b="0" i="0" sz="2400" u="none" cap="none" strike="noStrike">
+              <a:solidFill>
+                <a:schemeClr val="dk1"/>
+              </a:solidFill>
+              <a:latin typeface="Calibri"/>
+              <a:ea typeface="Calibri"/>
+              <a:cs typeface="Calibri"/>
+              <a:sym typeface="Calibri"/>
+            </a:endParaRPr>
+          </a:p>
+        </p:txBody>
+      </p:sp>
+      <p:sp>
+        <p:nvSpPr>
+          <p:cNvPr id="60" name="Rounded Rectangle 59"/>
+          <p:cNvSpPr/>
+          <p:nvPr/>
+        </p:nvSpPr>
+        <p:spPr>
+          <a:xfrm>
+            <a:off x="457200" y="1188720"/>
+            <a:ext cx="3931920" cy="3474720"/>
+          </a:xfrm>
+          <a:prstGeom prst="roundRect">
+            <a:avLst/>
+          </a:prstGeom>
+          <a:solidFill>
+            <a:srgbClr val="F8FAFC"/>
+          </a:solidFill>
+          <a:ln w="19050">
+            <a:solidFill>
+              <a:srgbClr val="E2E8F0"/>
+            </a:solidFill>
+          </a:ln>
+        </p:spPr>
+        <p:style>
+          <a:lnRef idx="1">
+            <a:schemeClr val="accent1"/>
+          </a:lnRef>
+          <a:fillRef idx="3">
+            <a:schemeClr val="accent1"/>
+          </a:fillRef>
+          <a:effectRef idx="2">
+            <a:schemeClr val="accent1"/>
+          </a:effectRef>
+          <a:fontRef idx="minor">
+            <a:schemeClr val="lt1"/>
+          </a:fontRef>
+        </p:style>
+        <p:txBody>
+          <a:bodyPr rtlCol="0" anchor="ctr" wrap="square"/>
+          <a:lstStyle/>
+          <a:p>
+            <a:pPr algn="ctr">
+              <a:spcAft>
+                <a:spcPts val="600"/>
+              </a:spcAft>
+              <a:defRPr b="1" sz="1200">
+                <a:solidFill>
+                  <a:srgbClr val="0F172A"/>
+                </a:solidFill>
+              </a:defRPr>
+            </a:pPr>
+            <a:r>
+              <a:t>Key Contributions (Checkpoint 1)</a:t>
+            </a:r>
+          </a:p>
+          <a:p>
+            <a:pPr>
+              <a:spcAft>
+                <a:spcPts val="400"/>
+              </a:spcAft>
+              <a:defRPr sz="950">
+                <a:solidFill>
+                  <a:srgbClr val="475569"/>
+                </a:solidFill>
+              </a:defRPr>
+            </a:pPr>
+            <a:r>
+              <a:t>• Comprehensive Pipeline: ResNet-18 + 4 Exit heads with NC1-NC4 automated logging.</a:t>
+            </a:r>
+          </a:p>
+          <a:p>
+            <a:pPr>
+              <a:spcAft>
+                <a:spcPts val="400"/>
+              </a:spcAft>
+              <a:defRPr sz="950">
+                <a:solidFill>
+                  <a:srgbClr val="475569"/>
+                </a:solidFill>
+              </a:defRPr>
+            </a:pPr>
+            <a:r>
+              <a:t>• Empirical Characterization: First systematic layer-wise collapse analysis on fine-grained visual classification.</a:t>
+            </a:r>
+          </a:p>
+          <a:p>
+            <a:pPr>
+              <a:spcAft>
+                <a:spcPts val="400"/>
+              </a:spcAft>
+              <a:defRPr sz="950">
+                <a:solidFill>
+                  <a:srgbClr val="475569"/>
+                </a:solidFill>
+              </a:defRPr>
+            </a:pPr>
+            <a:r>
+              <a:t>• Early Exit Pareto Front: Established Exit 3 as optimal trade-off boundary (1.25x speedup).</a:t>
+            </a:r>
+          </a:p>
+          <a:p>
+            <a:pPr>
+              <a:spcAft>
+                <a:spcPts val="400"/>
+              </a:spcAft>
+              <a:defRPr sz="950">
+                <a:solidFill>
+                  <a:srgbClr val="475569"/>
+                </a:solidFill>
+              </a:defRPr>
+            </a:pPr>
+            <a:r>
+              <a:t>• OOD &amp; Imbalance Auditing: Characterized layer-wise OOD AUROC and logit adjustment impact.</a:t>
+            </a:r>
+          </a:p>
+        </p:txBody>
+      </p:sp>
+      <p:sp>
+        <p:nvSpPr>
+          <p:cNvPr id="61" name="Rounded Rectangle 60"/>
+          <p:cNvSpPr/>
+          <p:nvPr/>
+        </p:nvSpPr>
+        <p:spPr>
+          <a:xfrm>
+            <a:off x="4754880" y="1188720"/>
+            <a:ext cx="3931920" cy="3474720"/>
+          </a:xfrm>
+          <a:prstGeom prst="roundRect">
+            <a:avLst/>
+          </a:prstGeom>
+          <a:solidFill>
+            <a:srgbClr val="F8FAFC"/>
+          </a:solidFill>
+          <a:ln w="19050">
+            <a:solidFill>
+              <a:srgbClr val="E2E8F0"/>
+            </a:solidFill>
+          </a:ln>
+        </p:spPr>
+        <p:style>
+          <a:lnRef idx="1">
+            <a:schemeClr val="accent1"/>
+          </a:lnRef>
+          <a:fillRef idx="3">
+            <a:schemeClr val="accent1"/>
+          </a:fillRef>
+          <a:effectRef idx="2">
+            <a:schemeClr val="accent1"/>
+          </a:effectRef>
+          <a:fontRef idx="minor">
+            <a:schemeClr val="lt1"/>
+          </a:fontRef>
+        </p:style>
+        <p:txBody>
+          <a:bodyPr rtlCol="0" anchor="ctr" wrap="square"/>
+          <a:lstStyle/>
+          <a:p>
+            <a:pPr algn="ctr">
+              <a:spcAft>
+                <a:spcPts val="600"/>
+              </a:spcAft>
+              <a:defRPr b="1" sz="1200">
+                <a:solidFill>
+                  <a:srgbClr val="0F172A"/>
+                </a:solidFill>
+              </a:defRPr>
+            </a:pPr>
+            <a:r>
+              <a:t>Future Research Directions (Checkpoint 2)</a:t>
+            </a:r>
+          </a:p>
+          <a:p>
+            <a:pPr>
+              <a:spcAft>
+                <a:spcPts val="400"/>
+              </a:spcAft>
+              <a:defRPr sz="950">
+                <a:solidFill>
+                  <a:srgbClr val="475569"/>
+                </a:solidFill>
+              </a:defRPr>
+            </a:pPr>
+            <a:r>
+              <a:t>• Cross-Dataset Comparison (CIFAR-10): Train identical pipeline on CIFAR-10 to test Munn et al. geometric complexity hypothesis.</a:t>
+            </a:r>
+          </a:p>
+          <a:p>
+            <a:pPr>
+              <a:spcAft>
+                <a:spcPts val="400"/>
+              </a:spcAft>
+              <a:defRPr sz="950">
+                <a:solidFill>
+                  <a:srgbClr val="475569"/>
+                </a:solidFill>
+              </a:defRPr>
+            </a:pPr>
+            <a:r>
+              <a:t>• Architecture Extension (DenseNet-121): Test whether dense feature reuse alters or preserves progressive NC.</a:t>
+            </a:r>
+          </a:p>
+          <a:p>
+            <a:pPr>
+              <a:spcAft>
+                <a:spcPts val="400"/>
+              </a:spcAft>
+              <a:defRPr sz="950">
+                <a:solidFill>
+                  <a:srgbClr val="475569"/>
+                </a:solidFill>
+              </a:defRPr>
+            </a:pPr>
+            <a:r>
+              <a:t>• Quantitative Statistical Correlation: Calculate Pearson &amp; Spearman r values for NC metrics vs exit accuracy.</a:t>
+            </a:r>
+          </a:p>
+          <a:p>
+            <a:pPr>
+              <a:spcAft>
+                <a:spcPts val="400"/>
+              </a:spcAft>
+              <a:defRPr sz="950">
+                <a:solidFill>
+                  <a:srgbClr val="475569"/>
+                </a:solidFill>
+              </a:defRPr>
+            </a:pPr>
+            <a:r>
+              <a:t>• Research Paper Draft: Prepare conference draft summarizing layer-wise representation geometry.</a:t>
+            </a:r>
+          </a:p>
+        </p:txBody>
+      </p:sp>
+    </p:spTree>
+  </p:cSld>
+  <p:clrMapOvr>
+    <a:masterClrMapping/>
+  </p:clrMapOvr>
+</p:sld>
+</file>
+
+<file path=ppt/slides/slide25.xml><?xml version="1.0" encoding="utf-8"?>
+<p:sld xmlns:a="http://schemas.openxmlformats.org/drawingml/2006/main" xmlns:p="http://schemas.openxmlformats.org/presentationml/2006/main" xmlns:r="http://schemas.openxmlformats.org/officeDocument/2006/relationships">
+  <p:cSld>
+    <p:spTree>
+      <p:nvGrpSpPr>
+        <p:cNvPr id="1" name=""/>
+        <p:cNvGrpSpPr/>
+        <p:nvPr/>
+      </p:nvGrpSpPr>
+      <p:grpSpPr/>
+      <p:sp>
+        <p:nvSpPr>
+          <p:cNvPr id="57" name="Google Shape;57;p5"/>
+          <p:cNvSpPr/>
+          <p:nvPr/>
+        </p:nvSpPr>
+        <p:spPr>
+          <a:xfrm>
+            <a:off x="0" y="0"/>
+            <a:ext cx="9144000" cy="667500"/>
+          </a:xfrm>
+          <a:prstGeom prst="rect">
+            <a:avLst/>
+          </a:prstGeom>
+          <a:solidFill>
+            <a:srgbClr val="000000"/>
+          </a:solidFill>
+          <a:ln cap="flat" cmpd="sng" w="12700">
+            <a:solidFill>
+              <a:srgbClr val="000000"/>
+            </a:solidFill>
+            <a:prstDash val="solid"/>
+            <a:round/>
+            <a:headEnd len="sm" w="sm" type="none"/>
+            <a:tailEnd len="sm" w="sm" type="none"/>
+          </a:ln>
+        </p:spPr>
+        <p:txBody>
+          <a:bodyPr anchorCtr="0" anchor="ctr" bIns="91425" lIns="91425" spcFirstLastPara="1" rIns="91425" wrap="square" tIns="91425">
+            <a:noAutofit/>
+          </a:bodyPr>
+          <a:lstStyle/>
+          <a:p>
+            <a:pPr indent="0" lvl="0" marL="0" rtl="0" algn="l">
+              <a:spcBef>
+                <a:spcPts val="0"/>
+              </a:spcBef>
+              <a:spcAft>
+                <a:spcPts val="0"/>
+              </a:spcAft>
+              <a:buNone/>
+            </a:pPr>
+            <a:r>
+              <a:t/>
+            </a:r>
+            <a:endParaRPr/>
+          </a:p>
+        </p:txBody>
+      </p:sp>
+      <p:pic>
+        <p:nvPicPr>
+          <p:cNvPr descr="/home/claude/kle_logo_final.png" id="58" name="Google Shape;58;p5"/>
+          <p:cNvPicPr preferRelativeResize="0"/>
+          <p:nvPr/>
+        </p:nvPicPr>
+        <p:blipFill rotWithShape="1">
+          <a:blip r:embed="rId3">
+            <a:alphaModFix/>
+          </a:blip>
+          <a:srcRect b="0" l="0" r="0" t="0"/>
+          <a:stretch/>
+        </p:blipFill>
+        <p:spPr>
+          <a:xfrm>
+            <a:off x="0" y="0"/>
+            <a:ext cx="667512" cy="667512"/>
+          </a:xfrm>
+          <a:prstGeom prst="rect">
+            <a:avLst/>
+          </a:prstGeom>
+          <a:noFill/>
+          <a:ln>
+            <a:noFill/>
+          </a:ln>
+        </p:spPr>
+      </p:pic>
+      <p:sp>
+        <p:nvSpPr>
+          <p:cNvPr id="59" name="Google Shape;59;p5"/>
+          <p:cNvSpPr/>
+          <p:nvPr/>
+        </p:nvSpPr>
+        <p:spPr>
+          <a:xfrm>
+            <a:off x="667512" y="0"/>
+            <a:ext cx="8476500" cy="667500"/>
+          </a:xfrm>
+          <a:prstGeom prst="rect">
+            <a:avLst/>
+          </a:prstGeom>
+          <a:noFill/>
+          <a:ln>
+            <a:noFill/>
+          </a:ln>
+        </p:spPr>
+        <p:txBody>
+          <a:bodyPr anchorCtr="0" anchor="ctr" bIns="0" lIns="0" spcFirstLastPara="1" rIns="0" wrap="square" tIns="0">
+            <a:noAutofit/>
+          </a:bodyPr>
+          <a:lstStyle/>
+          <a:p>
+            <a:pPr indent="0" lvl="0" marL="0" marR="0" rtl="0" algn="ctr">
+              <a:spcBef>
+                <a:spcPts val="0"/>
+              </a:spcBef>
+              <a:spcAft>
+                <a:spcPts val="0"/>
+              </a:spcAft>
+              <a:buClr>
+                <a:srgbClr val="FFFFFF"/>
+              </a:buClr>
+              <a:buSzPts val="2400"/>
+              <a:buFont typeface="Calibri"/>
+              <a:buNone/>
+            </a:pPr>
+            <a:r>
+              <a:t>Thank You</a:t>
+            </a:r>
+            <a:endParaRPr b="0" i="0" sz="2400" u="none" cap="none" strike="noStrike">
+              <a:solidFill>
+                <a:schemeClr val="dk1"/>
+              </a:solidFill>
+              <a:latin typeface="Calibri"/>
+              <a:ea typeface="Calibri"/>
+              <a:cs typeface="Calibri"/>
+              <a:sym typeface="Calibri"/>
+            </a:endParaRPr>
+          </a:p>
+        </p:txBody>
+      </p:sp>
+      <p:sp>
+        <p:nvSpPr>
           <p:cNvPr id="60" name="TextBox 59"/>
           <p:cNvSpPr txBox="1"/>
           <p:nvPr/>
@@ -16363,7 +17809,7 @@
               </a:defRPr>
             </a:pPr>
             <a:r>
-              <a:t>Layer-wise Analysis of Feature Evolution in CNNs</a:t>
+              <a:t>Feature Representation Dynamics and Reliability in Deep Neural Image Classification</a:t>
             </a:r>
           </a:p>
           <a:p>
@@ -16390,7 +17836,7 @@
               </a:defRPr>
             </a:pPr>
             <a:r>
-              <a:t>Questions?</a:t>
+              <a:t>Questions &amp; Discussion</a:t>
             </a:r>
           </a:p>
         </p:txBody>

</xml_diff>